<commit_message>
Add a title slide to the PhD-seminar talk
Cover slide matching the supervisor deck's hero style, framed for
discussion. Content footers renumbered to N/6 with the cover unnumbered.

Co-Authored-By: Claude Opus 4.8 <noreply@anthropic.com>
</commit_message>
<xml_diff>
--- a/docs/PHD_TALK_2026-06-04.pptx
+++ b/docs/PHD_TALK_2026-06-04.pptx
@@ -10,6 +10,7 @@
     <p:sldId id="258" r:id="rId9"/>
     <p:sldId id="259" r:id="rId10"/>
     <p:sldId id="260" r:id="rId11"/>
+    <p:sldId id="261" r:id="rId12"/>
   </p:sldIdLst>
   <p:sldSz cx="9144000" cy="5143500" type="screen4x3"/>
   <p:notesSz cx="6858000" cy="9144000"/>
@@ -3101,7 +3102,7 @@
         <p:spPr>
           <a:xfrm>
             <a:off x="0" y="0"/>
-            <a:ext cx="9144000" cy="960120"/>
+            <a:ext cx="9144000" cy="5143500"/>
           </a:xfrm>
           <a:prstGeom prst="rect">
             <a:avLst/>
@@ -3137,129 +3138,14 @@
       </p:sp>
       <p:sp>
         <p:nvSpPr>
-          <p:cNvPr id="3" name="TextBox 2"/>
-          <p:cNvSpPr txBox="1"/>
-          <p:nvPr/>
-        </p:nvSpPr>
-        <p:spPr>
-          <a:xfrm>
-            <a:off x="457200" y="164592"/>
-            <a:ext cx="7772400" cy="228600"/>
-          </a:xfrm>
-          <a:prstGeom prst="rect">
-            <a:avLst/>
-          </a:prstGeom>
-          <a:noFill/>
-        </p:spPr>
-        <p:txBody>
-          <a:bodyPr wrap="square" lIns="0" rIns="0" tIns="0" bIns="0">
-            <a:spAutoFit/>
-          </a:bodyPr>
-          <a:lstStyle/>
-          <a:p>
-            <a:pPr algn="l"/>
-            <a:r>
-              <a:rPr sz="900" b="1">
-                <a:solidFill>
-                  <a:srgbClr val="14B8A6"/>
-                </a:solidFill>
-                <a:latin typeface="Calibri"/>
-              </a:rPr>
-              <a:t>SYSTEM AND HONEST STATUS</a:t>
-            </a:r>
-          </a:p>
-        </p:txBody>
-      </p:sp>
-      <p:sp>
-        <p:nvSpPr>
-          <p:cNvPr id="4" name="TextBox 3"/>
-          <p:cNvSpPr txBox="1"/>
-          <p:nvPr/>
-        </p:nvSpPr>
-        <p:spPr>
-          <a:xfrm>
-            <a:off x="457200" y="384048"/>
-            <a:ext cx="7772400" cy="502920"/>
-          </a:xfrm>
-          <a:prstGeom prst="rect">
-            <a:avLst/>
-          </a:prstGeom>
-          <a:noFill/>
-        </p:spPr>
-        <p:txBody>
-          <a:bodyPr wrap="square" lIns="0" rIns="0" tIns="0" bIns="0">
-            <a:spAutoFit/>
-          </a:bodyPr>
-          <a:lstStyle/>
-          <a:p>
-            <a:pPr algn="l"/>
-            <a:r>
-              <a:rPr sz="2400" b="1">
-                <a:solidFill>
-                  <a:srgbClr val="FFFFFF"/>
-                </a:solidFill>
-                <a:latin typeface="Calibri"/>
-              </a:rPr>
-              <a:t>An adversarial swarm, scored against ODMI's own answers</a:t>
-            </a:r>
-          </a:p>
-        </p:txBody>
-      </p:sp>
-      <p:sp>
-        <p:nvSpPr>
-          <p:cNvPr id="5" name="Rectangle 4"/>
+          <p:cNvPr id="3" name="Rectangle 2"/>
           <p:cNvSpPr/>
           <p:nvPr/>
         </p:nvSpPr>
         <p:spPr>
           <a:xfrm>
-            <a:off x="457200" y="1188720"/>
-            <a:ext cx="2468880" cy="1280160"/>
-          </a:xfrm>
-          <a:prstGeom prst="rect">
-            <a:avLst/>
-          </a:prstGeom>
-          <a:solidFill>
-            <a:srgbClr val="FFFFFF"/>
-          </a:solidFill>
-          <a:ln w="6350">
-            <a:solidFill>
-              <a:srgbClr val="E2E8F0"/>
-            </a:solidFill>
-          </a:ln>
-        </p:spPr>
-        <p:style>
-          <a:lnRef idx="1">
-            <a:schemeClr val="accent1"/>
-          </a:lnRef>
-          <a:fillRef idx="3">
-            <a:schemeClr val="accent1"/>
-          </a:fillRef>
-          <a:effectRef idx="2">
-            <a:schemeClr val="accent1"/>
-          </a:effectRef>
-          <a:fontRef idx="minor">
-            <a:schemeClr val="lt1"/>
-          </a:fontRef>
-        </p:style>
-        <p:txBody>
-          <a:bodyPr rtlCol="0" anchor="ctr"/>
-          <a:lstStyle/>
-          <a:p>
-            <a:pPr algn="ctr"/>
-          </a:p>
-        </p:txBody>
-      </p:sp>
-      <p:sp>
-        <p:nvSpPr>
-          <p:cNvPr id="6" name="Rectangle 5"/>
-          <p:cNvSpPr/>
-          <p:nvPr/>
-        </p:nvSpPr>
-        <p:spPr>
-          <a:xfrm>
-            <a:off x="457200" y="1188720"/>
-            <a:ext cx="2468880" cy="320040"/>
+            <a:off x="0" y="1828800"/>
+            <a:ext cx="548640" cy="1828800"/>
           </a:xfrm>
           <a:prstGeom prst="rect">
             <a:avLst/>
@@ -3295,14 +3181,14 @@
       </p:sp>
       <p:sp>
         <p:nvSpPr>
-          <p:cNvPr id="7" name="TextBox 6"/>
+          <p:cNvPr id="4" name="TextBox 3"/>
           <p:cNvSpPr txBox="1"/>
           <p:nvPr/>
         </p:nvSpPr>
         <p:spPr>
           <a:xfrm>
-            <a:off x="640080" y="1234440"/>
-            <a:ext cx="2103120" cy="246888"/>
+            <a:off x="914400" y="1097280"/>
+            <a:ext cx="7772400" cy="365760"/>
           </a:xfrm>
           <a:prstGeom prst="rect">
             <a:avLst/>
@@ -3317,27 +3203,27 @@
           <a:p>
             <a:pPr algn="l"/>
             <a:r>
-              <a:rPr sz="1200" b="1">
-                <a:solidFill>
-                  <a:srgbClr val="FFFFFF"/>
+              <a:rPr sz="1000" b="1">
+                <a:solidFill>
+                  <a:srgbClr val="14B8A6"/>
                 </a:solidFill>
                 <a:latin typeface="Calibri"/>
               </a:rPr>
-              <a:t>RESEARCHER</a:t>
-            </a:r>
-          </a:p>
-        </p:txBody>
-      </p:sp>
-      <p:sp>
-        <p:nvSpPr>
-          <p:cNvPr id="8" name="TextBox 7"/>
+              <a:t>MSc ADVANCED COMPUTING · PhD SEMINAR · FOR DISCUSSION</a:t>
+            </a:r>
+          </a:p>
+        </p:txBody>
+      </p:sp>
+      <p:sp>
+        <p:nvSpPr>
+          <p:cNvPr id="5" name="TextBox 4"/>
           <p:cNvSpPr txBox="1"/>
           <p:nvPr/>
         </p:nvSpPr>
         <p:spPr>
           <a:xfrm>
-            <a:off x="640080" y="1645920"/>
-            <a:ext cx="2103120" cy="731520"/>
+            <a:off x="914400" y="1508760"/>
+            <a:ext cx="7772400" cy="2011680"/>
           </a:xfrm>
           <a:prstGeom prst="rect">
             <a:avLst/>
@@ -3350,117 +3236,50 @@
           </a:bodyPr>
           <a:lstStyle/>
           <a:p>
-            <a:pPr algn="l"/>
-            <a:r>
-              <a:rPr sz="1000" b="0">
-                <a:solidFill>
-                  <a:srgbClr val="2D3748"/>
+            <a:r>
+              <a:rPr sz="4000" b="1">
+                <a:solidFill>
+                  <a:srgbClr val="FFFFFF"/>
                 </a:solidFill>
                 <a:latin typeface="Calibri"/>
               </a:rPr>
-              <a:t>Searches, fetches, reasons. Returns answer + source URL + quoted passage + confidence.</a:t>
-            </a:r>
-          </a:p>
-        </p:txBody>
-      </p:sp>
-      <p:sp>
-        <p:nvSpPr>
-          <p:cNvPr id="9" name="Rectangle 8"/>
-          <p:cNvSpPr/>
-          <p:nvPr/>
-        </p:nvSpPr>
-        <p:spPr>
-          <a:xfrm>
-            <a:off x="3337560" y="1188720"/>
-            <a:ext cx="2468880" cy="1280160"/>
-          </a:xfrm>
-          <a:prstGeom prst="rect">
-            <a:avLst/>
-          </a:prstGeom>
-          <a:solidFill>
-            <a:srgbClr val="FFFFFF"/>
-          </a:solidFill>
-          <a:ln w="6350">
-            <a:solidFill>
-              <a:srgbClr val="E2E8F0"/>
-            </a:solidFill>
-          </a:ln>
-        </p:spPr>
-        <p:style>
-          <a:lnRef idx="1">
-            <a:schemeClr val="accent1"/>
-          </a:lnRef>
-          <a:fillRef idx="3">
-            <a:schemeClr val="accent1"/>
-          </a:fillRef>
-          <a:effectRef idx="2">
-            <a:schemeClr val="accent1"/>
-          </a:effectRef>
-          <a:fontRef idx="minor">
-            <a:schemeClr val="lt1"/>
-          </a:fontRef>
-        </p:style>
-        <p:txBody>
-          <a:bodyPr rtlCol="0" anchor="ctr"/>
-          <a:lstStyle/>
-          <a:p>
-            <a:pPr algn="ctr"/>
-          </a:p>
-        </p:txBody>
-      </p:sp>
-      <p:sp>
-        <p:nvSpPr>
-          <p:cNvPr id="10" name="Rectangle 9"/>
-          <p:cNvSpPr/>
-          <p:nvPr/>
-        </p:nvSpPr>
-        <p:spPr>
-          <a:xfrm>
-            <a:off x="3337560" y="1188720"/>
-            <a:ext cx="2468880" cy="320040"/>
-          </a:xfrm>
-          <a:prstGeom prst="rect">
-            <a:avLst/>
-          </a:prstGeom>
-          <a:solidFill>
-            <a:srgbClr val="1E3A5F"/>
-          </a:solidFill>
-          <a:ln>
-            <a:noFill/>
-          </a:ln>
-        </p:spPr>
-        <p:style>
-          <a:lnRef idx="1">
-            <a:schemeClr val="accent1"/>
-          </a:lnRef>
-          <a:fillRef idx="3">
-            <a:schemeClr val="accent1"/>
-          </a:fillRef>
-          <a:effectRef idx="2">
-            <a:schemeClr val="accent1"/>
-          </a:effectRef>
-          <a:fontRef idx="minor">
-            <a:schemeClr val="lt1"/>
-          </a:fontRef>
-        </p:style>
-        <p:txBody>
-          <a:bodyPr rtlCol="0" anchor="ctr"/>
-          <a:lstStyle/>
-          <a:p>
-            <a:pPr algn="ctr"/>
-          </a:p>
-        </p:txBody>
-      </p:sp>
-      <p:sp>
-        <p:nvSpPr>
-          <p:cNvPr id="11" name="TextBox 10"/>
+              <a:t>Agentic AI for Open</a:t>
+            </a:r>
+          </a:p>
+          <a:p>
+            <a:r>
+              <a:rPr sz="4000" b="1">
+                <a:solidFill>
+                  <a:srgbClr val="FFFFFF"/>
+                </a:solidFill>
+                <a:latin typeface="Calibri"/>
+              </a:rPr>
+              <a:t>Data Maturity</a:t>
+            </a:r>
+          </a:p>
+          <a:p>
+            <a:r>
+              <a:rPr sz="4000" b="1">
+                <a:solidFill>
+                  <a:srgbClr val="FFFFFF"/>
+                </a:solidFill>
+                <a:latin typeface="Calibri"/>
+              </a:rPr>
+              <a:t>Assessment</a:t>
+            </a:r>
+          </a:p>
+        </p:txBody>
+      </p:sp>
+      <p:sp>
+        <p:nvSpPr>
+          <p:cNvPr id="6" name="TextBox 5"/>
           <p:cNvSpPr txBox="1"/>
           <p:nvPr/>
         </p:nvSpPr>
         <p:spPr>
           <a:xfrm>
-            <a:off x="3520440" y="1234440"/>
-            <a:ext cx="2103120" cy="246888"/>
+            <a:off x="914400" y="3657600"/>
+            <a:ext cx="7772400" cy="548640"/>
           </a:xfrm>
           <a:prstGeom prst="rect">
             <a:avLst/>
@@ -3475,27 +3294,27 @@
           <a:p>
             <a:pPr algn="l"/>
             <a:r>
-              <a:rPr sz="1200" b="1">
-                <a:solidFill>
-                  <a:srgbClr val="FFFFFF"/>
+              <a:rPr sz="1400" b="0">
+                <a:solidFill>
+                  <a:srgbClr val="CBD5E0"/>
                 </a:solidFill>
                 <a:latin typeface="Calibri"/>
               </a:rPr>
-              <a:t>VERIFIER</a:t>
-            </a:r>
-          </a:p>
-        </p:txBody>
-      </p:sp>
-      <p:sp>
-        <p:nvSpPr>
-          <p:cNvPr id="12" name="TextBox 11"/>
+              <a:t>Method, experiments, and the open questions I want your view on</a:t>
+            </a:r>
+          </a:p>
+        </p:txBody>
+      </p:sp>
+      <p:sp>
+        <p:nvSpPr>
+          <p:cNvPr id="7" name="TextBox 6"/>
           <p:cNvSpPr txBox="1"/>
           <p:nvPr/>
         </p:nvSpPr>
         <p:spPr>
           <a:xfrm>
-            <a:off x="3520440" y="1645920"/>
-            <a:ext cx="2103120" cy="731520"/>
+            <a:off x="914400" y="4572000"/>
+            <a:ext cx="7772400" cy="365760"/>
           </a:xfrm>
           <a:prstGeom prst="rect">
             <a:avLst/>
@@ -3510,450 +3329,13 @@
           <a:p>
             <a:pPr algn="l"/>
             <a:r>
-              <a:rPr sz="1000" b="0">
-                <a:solidFill>
-                  <a:srgbClr val="2D3748"/>
+              <a:rPr sz="1100" b="0">
+                <a:solidFill>
+                  <a:srgbClr val="FFFFFF"/>
                 </a:solidFill>
                 <a:latin typeface="Calibri"/>
               </a:rPr>
-              <a:t>Independent search, prompted to disprove. Returns pass / fail with counter-evidence.</a:t>
-            </a:r>
-          </a:p>
-        </p:txBody>
-      </p:sp>
-      <p:sp>
-        <p:nvSpPr>
-          <p:cNvPr id="13" name="Rectangle 12"/>
-          <p:cNvSpPr/>
-          <p:nvPr/>
-        </p:nvSpPr>
-        <p:spPr>
-          <a:xfrm>
-            <a:off x="6217920" y="1188720"/>
-            <a:ext cx="2468880" cy="1280160"/>
-          </a:xfrm>
-          <a:prstGeom prst="rect">
-            <a:avLst/>
-          </a:prstGeom>
-          <a:solidFill>
-            <a:srgbClr val="FFFFFF"/>
-          </a:solidFill>
-          <a:ln w="6350">
-            <a:solidFill>
-              <a:srgbClr val="E2E8F0"/>
-            </a:solidFill>
-          </a:ln>
-        </p:spPr>
-        <p:style>
-          <a:lnRef idx="1">
-            <a:schemeClr val="accent1"/>
-          </a:lnRef>
-          <a:fillRef idx="3">
-            <a:schemeClr val="accent1"/>
-          </a:fillRef>
-          <a:effectRef idx="2">
-            <a:schemeClr val="accent1"/>
-          </a:effectRef>
-          <a:fontRef idx="minor">
-            <a:schemeClr val="lt1"/>
-          </a:fontRef>
-        </p:style>
-        <p:txBody>
-          <a:bodyPr rtlCol="0" anchor="ctr"/>
-          <a:lstStyle/>
-          <a:p>
-            <a:pPr algn="ctr"/>
-          </a:p>
-        </p:txBody>
-      </p:sp>
-      <p:sp>
-        <p:nvSpPr>
-          <p:cNvPr id="14" name="Rectangle 13"/>
-          <p:cNvSpPr/>
-          <p:nvPr/>
-        </p:nvSpPr>
-        <p:spPr>
-          <a:xfrm>
-            <a:off x="6217920" y="1188720"/>
-            <a:ext cx="2468880" cy="320040"/>
-          </a:xfrm>
-          <a:prstGeom prst="rect">
-            <a:avLst/>
-          </a:prstGeom>
-          <a:solidFill>
-            <a:srgbClr val="C53030"/>
-          </a:solidFill>
-          <a:ln>
-            <a:noFill/>
-          </a:ln>
-        </p:spPr>
-        <p:style>
-          <a:lnRef idx="1">
-            <a:schemeClr val="accent1"/>
-          </a:lnRef>
-          <a:fillRef idx="3">
-            <a:schemeClr val="accent1"/>
-          </a:fillRef>
-          <a:effectRef idx="2">
-            <a:schemeClr val="accent1"/>
-          </a:effectRef>
-          <a:fontRef idx="minor">
-            <a:schemeClr val="lt1"/>
-          </a:fontRef>
-        </p:style>
-        <p:txBody>
-          <a:bodyPr rtlCol="0" anchor="ctr"/>
-          <a:lstStyle/>
-          <a:p>
-            <a:pPr algn="ctr"/>
-          </a:p>
-        </p:txBody>
-      </p:sp>
-      <p:sp>
-        <p:nvSpPr>
-          <p:cNvPr id="15" name="TextBox 14"/>
-          <p:cNvSpPr txBox="1"/>
-          <p:nvPr/>
-        </p:nvSpPr>
-        <p:spPr>
-          <a:xfrm>
-            <a:off x="6400800" y="1234440"/>
-            <a:ext cx="2103120" cy="246888"/>
-          </a:xfrm>
-          <a:prstGeom prst="rect">
-            <a:avLst/>
-          </a:prstGeom>
-          <a:noFill/>
-        </p:spPr>
-        <p:txBody>
-          <a:bodyPr wrap="square" lIns="0" rIns="0" tIns="0" bIns="0">
-            <a:spAutoFit/>
-          </a:bodyPr>
-          <a:lstStyle/>
-          <a:p>
-            <a:pPr algn="l"/>
-            <a:r>
-              <a:rPr sz="1200" b="1">
-                <a:solidFill>
-                  <a:srgbClr val="FFFFFF"/>
-                </a:solidFill>
-                <a:latin typeface="Calibri"/>
-              </a:rPr>
-              <a:t>ADJUDICATOR</a:t>
-            </a:r>
-          </a:p>
-        </p:txBody>
-      </p:sp>
-      <p:sp>
-        <p:nvSpPr>
-          <p:cNvPr id="16" name="TextBox 15"/>
-          <p:cNvSpPr txBox="1"/>
-          <p:nvPr/>
-        </p:nvSpPr>
-        <p:spPr>
-          <a:xfrm>
-            <a:off x="6400800" y="1645920"/>
-            <a:ext cx="2103120" cy="731520"/>
-          </a:xfrm>
-          <a:prstGeom prst="rect">
-            <a:avLst/>
-          </a:prstGeom>
-          <a:noFill/>
-        </p:spPr>
-        <p:txBody>
-          <a:bodyPr wrap="square" lIns="0" rIns="0" tIns="0" bIns="0">
-            <a:spAutoFit/>
-          </a:bodyPr>
-          <a:lstStyle/>
-          <a:p>
-            <a:pPr algn="l"/>
-            <a:r>
-              <a:rPr sz="1000" b="0">
-                <a:solidFill>
-                  <a:srgbClr val="2D3748"/>
-                </a:solidFill>
-                <a:latin typeface="Calibri"/>
-              </a:rPr>
-              <a:t>Fires on retry exhaustion. Reads the full history, commits above the 0.65 floor or abstains.</a:t>
-            </a:r>
-          </a:p>
-        </p:txBody>
-      </p:sp>
-      <p:sp>
-        <p:nvSpPr>
-          <p:cNvPr id="17" name="Right Arrow 16"/>
-          <p:cNvSpPr/>
-          <p:nvPr/>
-        </p:nvSpPr>
-        <p:spPr>
-          <a:xfrm>
-            <a:off x="2971800" y="1719072"/>
-            <a:ext cx="320040" cy="219456"/>
-          </a:xfrm>
-          <a:prstGeom prst="rightArrow">
-            <a:avLst/>
-          </a:prstGeom>
-          <a:solidFill>
-            <a:srgbClr val="718096"/>
-          </a:solidFill>
-          <a:ln>
-            <a:noFill/>
-          </a:ln>
-        </p:spPr>
-        <p:style>
-          <a:lnRef idx="1">
-            <a:schemeClr val="accent1"/>
-          </a:lnRef>
-          <a:fillRef idx="3">
-            <a:schemeClr val="accent1"/>
-          </a:fillRef>
-          <a:effectRef idx="2">
-            <a:schemeClr val="accent1"/>
-          </a:effectRef>
-          <a:fontRef idx="minor">
-            <a:schemeClr val="lt1"/>
-          </a:fontRef>
-        </p:style>
-        <p:txBody>
-          <a:bodyPr rtlCol="0" anchor="ctr"/>
-          <a:lstStyle/>
-          <a:p>
-            <a:pPr algn="ctr"/>
-          </a:p>
-        </p:txBody>
-      </p:sp>
-      <p:sp>
-        <p:nvSpPr>
-          <p:cNvPr id="18" name="Right Arrow 17"/>
-          <p:cNvSpPr/>
-          <p:nvPr/>
-        </p:nvSpPr>
-        <p:spPr>
-          <a:xfrm>
-            <a:off x="5852160" y="1719072"/>
-            <a:ext cx="320040" cy="219456"/>
-          </a:xfrm>
-          <a:prstGeom prst="rightArrow">
-            <a:avLst/>
-          </a:prstGeom>
-          <a:solidFill>
-            <a:srgbClr val="718096"/>
-          </a:solidFill>
-          <a:ln>
-            <a:noFill/>
-          </a:ln>
-        </p:spPr>
-        <p:style>
-          <a:lnRef idx="1">
-            <a:schemeClr val="accent1"/>
-          </a:lnRef>
-          <a:fillRef idx="3">
-            <a:schemeClr val="accent1"/>
-          </a:fillRef>
-          <a:effectRef idx="2">
-            <a:schemeClr val="accent1"/>
-          </a:effectRef>
-          <a:fontRef idx="minor">
-            <a:schemeClr val="lt1"/>
-          </a:fontRef>
-        </p:style>
-        <p:txBody>
-          <a:bodyPr rtlCol="0" anchor="ctr"/>
-          <a:lstStyle/>
-          <a:p>
-            <a:pPr algn="ctr"/>
-          </a:p>
-        </p:txBody>
-      </p:sp>
-      <p:sp>
-        <p:nvSpPr>
-          <p:cNvPr id="19" name="Rectangle 18"/>
-          <p:cNvSpPr/>
-          <p:nvPr/>
-        </p:nvSpPr>
-        <p:spPr>
-          <a:xfrm>
-            <a:off x="457200" y="2788920"/>
-            <a:ext cx="8229600" cy="1508760"/>
-          </a:xfrm>
-          <a:prstGeom prst="rect">
-            <a:avLst/>
-          </a:prstGeom>
-          <a:solidFill>
-            <a:srgbClr val="FFFFFF"/>
-          </a:solidFill>
-          <a:ln w="6350">
-            <a:solidFill>
-              <a:srgbClr val="E2E8F0"/>
-            </a:solidFill>
-          </a:ln>
-        </p:spPr>
-        <p:style>
-          <a:lnRef idx="1">
-            <a:schemeClr val="accent1"/>
-          </a:lnRef>
-          <a:fillRef idx="3">
-            <a:schemeClr val="accent1"/>
-          </a:fillRef>
-          <a:effectRef idx="2">
-            <a:schemeClr val="accent1"/>
-          </a:effectRef>
-          <a:fontRef idx="minor">
-            <a:schemeClr val="lt1"/>
-          </a:fontRef>
-        </p:style>
-        <p:txBody>
-          <a:bodyPr rtlCol="0" anchor="ctr"/>
-          <a:lstStyle/>
-          <a:p>
-            <a:pPr algn="ctr"/>
-          </a:p>
-        </p:txBody>
-      </p:sp>
-      <p:sp>
-        <p:nvSpPr>
-          <p:cNvPr id="20" name="Rectangle 19"/>
-          <p:cNvSpPr/>
-          <p:nvPr/>
-        </p:nvSpPr>
-        <p:spPr>
-          <a:xfrm>
-            <a:off x="457200" y="2788920"/>
-            <a:ext cx="73152" cy="1508760"/>
-          </a:xfrm>
-          <a:prstGeom prst="rect">
-            <a:avLst/>
-          </a:prstGeom>
-          <a:solidFill>
-            <a:srgbClr val="0D9488"/>
-          </a:solidFill>
-          <a:ln>
-            <a:noFill/>
-          </a:ln>
-        </p:spPr>
-        <p:style>
-          <a:lnRef idx="1">
-            <a:schemeClr val="accent1"/>
-          </a:lnRef>
-          <a:fillRef idx="3">
-            <a:schemeClr val="accent1"/>
-          </a:fillRef>
-          <a:effectRef idx="2">
-            <a:schemeClr val="accent1"/>
-          </a:effectRef>
-          <a:fontRef idx="minor">
-            <a:schemeClr val="lt1"/>
-          </a:fontRef>
-        </p:style>
-        <p:txBody>
-          <a:bodyPr rtlCol="0" anchor="ctr"/>
-          <a:lstStyle/>
-          <a:p>
-            <a:pPr algn="ctr"/>
-          </a:p>
-        </p:txBody>
-      </p:sp>
-      <p:sp>
-        <p:nvSpPr>
-          <p:cNvPr id="21" name="TextBox 20"/>
-          <p:cNvSpPr txBox="1"/>
-          <p:nvPr/>
-        </p:nvSpPr>
-        <p:spPr>
-          <a:xfrm>
-            <a:off x="850392" y="2926080"/>
-            <a:ext cx="7607808" cy="320040"/>
-          </a:xfrm>
-          <a:prstGeom prst="rect">
-            <a:avLst/>
-          </a:prstGeom>
-          <a:noFill/>
-        </p:spPr>
-        <p:txBody>
-          <a:bodyPr wrap="square" lIns="0" rIns="0" tIns="0" bIns="0">
-            <a:spAutoFit/>
-          </a:bodyPr>
-          <a:lstStyle/>
-          <a:p>
-            <a:pPr algn="l"/>
-            <a:r>
-              <a:rPr sz="1400" b="1">
-                <a:solidFill>
-                  <a:srgbClr val="1A202C"/>
-                </a:solidFill>
-                <a:latin typeface="Calibri"/>
-              </a:rPr>
-              <a:t>What is actually run, and what is not</a:t>
-            </a:r>
-          </a:p>
-        </p:txBody>
-      </p:sp>
-      <p:sp>
-        <p:nvSpPr>
-          <p:cNvPr id="22" name="TextBox 21"/>
-          <p:cNvSpPr txBox="1"/>
-          <p:nvPr/>
-        </p:nvSpPr>
-        <p:spPr>
-          <a:xfrm>
-            <a:off x="850392" y="3246120"/>
-            <a:ext cx="7607808" cy="1005840"/>
-          </a:xfrm>
-          <a:prstGeom prst="rect">
-            <a:avLst/>
-          </a:prstGeom>
-          <a:noFill/>
-        </p:spPr>
-        <p:txBody>
-          <a:bodyPr wrap="square" lIns="0" rIns="0" tIns="0" bIns="0">
-            <a:spAutoFit/>
-          </a:bodyPr>
-          <a:lstStyle/>
-          <a:p>
-            <a:pPr algn="l"/>
-            <a:r>
-              <a:rPr sz="1100" b="0">
-                <a:solidFill>
-                  <a:srgbClr val="2D3748"/>
-                </a:solidFill>
-                <a:latin typeface="Calibri"/>
-              </a:rPr>
-              <a:t>Plain Python state machine, Claude via CLIProxyAPI. Every call logs model + prompt version + raw response + cost, so an examiner replays it from logs alone. Run and adjudicated: EXP-1 (DIY vs Tavily), the Malta base-rate baseline (60/60), and the independent catalogue recompute. Everything else is pre-registered and built, gated on search and Claude quota. 222 pairs finalised, 5,148 ODMI ground-truth rows loaded.</a:t>
-            </a:r>
-          </a:p>
-        </p:txBody>
-      </p:sp>
-      <p:sp>
-        <p:nvSpPr>
-          <p:cNvPr id="23" name="TextBox 22"/>
-          <p:cNvSpPr txBox="1"/>
-          <p:nvPr/>
-        </p:nvSpPr>
-        <p:spPr>
-          <a:xfrm>
-            <a:off x="457200" y="4850892"/>
-            <a:ext cx="8229600" cy="182880"/>
-          </a:xfrm>
-          <a:prstGeom prst="rect">
-            <a:avLst/>
-          </a:prstGeom>
-          <a:noFill/>
-        </p:spPr>
-        <p:txBody>
-          <a:bodyPr wrap="square" lIns="0" rIns="0" tIns="0" bIns="0">
-            <a:spAutoFit/>
-          </a:bodyPr>
-          <a:lstStyle/>
-          <a:p>
-            <a:pPr algn="l"/>
-            <a:r>
-              <a:rPr sz="800" b="0">
-                <a:solidFill>
-                  <a:srgbClr val="718096"/>
-                </a:solidFill>
-                <a:latin typeface="Calibri"/>
-              </a:rPr>
-              <a:t>ODMI Agent Swarm  ·  Benjy Bream  ·  King's College London  ·  1 / 5</a:t>
+              <a:t>Benjy Bream  ·  King's College London  ·  04 June 2026</a:t>
             </a:r>
           </a:p>
         </p:txBody>
@@ -4049,7 +3431,7 @@
                 </a:solidFill>
                 <a:latin typeface="Calibri"/>
               </a:rPr>
-              <a:t>IMPARTIALITY DESIGNED IN, NOT ASSERTED</a:t>
+              <a:t>SYSTEM AND HONEST STATUS</a:t>
             </a:r>
           </a:p>
         </p:txBody>
@@ -4084,7 +3466,7 @@
                 </a:solidFill>
                 <a:latin typeface="Calibri"/>
               </a:rPr>
-              <a:t>Keeping the evaluation honest</a:t>
+              <a:t>An adversarial swarm, scored against ODMI's own answers</a:t>
             </a:r>
           </a:p>
         </p:txBody>
@@ -4097,8 +3479,8 @@
         </p:nvSpPr>
         <p:spPr>
           <a:xfrm>
-            <a:off x="457200" y="1143000"/>
-            <a:ext cx="4069080" cy="1463040"/>
+            <a:off x="457200" y="1188720"/>
+            <a:ext cx="2468880" cy="1280160"/>
           </a:xfrm>
           <a:prstGeom prst="rect">
             <a:avLst/>
@@ -4142,8 +3524,8 @@
         </p:nvSpPr>
         <p:spPr>
           <a:xfrm>
-            <a:off x="457200" y="1143000"/>
-            <a:ext cx="73152" cy="1463040"/>
+            <a:off x="457200" y="1188720"/>
+            <a:ext cx="2468880" cy="320040"/>
           </a:xfrm>
           <a:prstGeom prst="rect">
             <a:avLst/>
@@ -4185,8 +3567,8 @@
         </p:nvSpPr>
         <p:spPr>
           <a:xfrm>
-            <a:off x="850392" y="1280160"/>
-            <a:ext cx="3447288" cy="320040"/>
+            <a:off x="640080" y="1234440"/>
+            <a:ext cx="2103120" cy="246888"/>
           </a:xfrm>
           <a:prstGeom prst="rect">
             <a:avLst/>
@@ -4201,13 +3583,13 @@
           <a:p>
             <a:pPr algn="l"/>
             <a:r>
-              <a:rPr sz="1400" b="1">
-                <a:solidFill>
-                  <a:srgbClr val="1A202C"/>
+              <a:rPr sz="1200" b="1">
+                <a:solidFill>
+                  <a:srgbClr val="FFFFFF"/>
                 </a:solidFill>
                 <a:latin typeface="Calibri"/>
               </a:rPr>
-              <a:t>Pre-registered before the data (R1)</a:t>
+              <a:t>RESEARCHER</a:t>
             </a:r>
           </a:p>
         </p:txBody>
@@ -4220,8 +3602,8 @@
         </p:nvSpPr>
         <p:spPr>
           <a:xfrm>
-            <a:off x="850392" y="1600200"/>
-            <a:ext cx="3447288" cy="960120"/>
+            <a:off x="640080" y="1645920"/>
+            <a:ext cx="2103120" cy="731520"/>
           </a:xfrm>
           <a:prstGeom prst="rect">
             <a:avLst/>
@@ -4236,13 +3618,13 @@
           <a:p>
             <a:pPr algn="l"/>
             <a:r>
-              <a:rPr sz="1100" b="0">
+              <a:rPr sz="1000" b="0">
                 <a:solidFill>
                   <a:srgbClr val="2D3748"/>
                 </a:solidFill>
                 <a:latin typeface="Calibri"/>
               </a:rPr>
-              <a:t>Each design is fixed in a dated git commit whose timestamp predates its result file. The run decides the answer, nothing else. No reverse-fitting.</a:t>
+              <a:t>Searches, fetches, reasons. Returns answer + source URL + quoted passage + confidence.</a:t>
             </a:r>
           </a:p>
         </p:txBody>
@@ -4255,8 +3637,8 @@
         </p:nvSpPr>
         <p:spPr>
           <a:xfrm>
-            <a:off x="4617720" y="1143000"/>
-            <a:ext cx="4069080" cy="1463040"/>
+            <a:off x="3337560" y="1188720"/>
+            <a:ext cx="2468880" cy="1280160"/>
           </a:xfrm>
           <a:prstGeom prst="rect">
             <a:avLst/>
@@ -4300,8 +3682,8 @@
         </p:nvSpPr>
         <p:spPr>
           <a:xfrm>
-            <a:off x="4617720" y="1143000"/>
-            <a:ext cx="73152" cy="1463040"/>
+            <a:off x="3337560" y="1188720"/>
+            <a:ext cx="2468880" cy="320040"/>
           </a:xfrm>
           <a:prstGeom prst="rect">
             <a:avLst/>
@@ -4343,8 +3725,8 @@
         </p:nvSpPr>
         <p:spPr>
           <a:xfrm>
-            <a:off x="5010912" y="1280160"/>
-            <a:ext cx="3447288" cy="320040"/>
+            <a:off x="3520440" y="1234440"/>
+            <a:ext cx="2103120" cy="246888"/>
           </a:xfrm>
           <a:prstGeom prst="rect">
             <a:avLst/>
@@ -4359,13 +3741,13 @@
           <a:p>
             <a:pPr algn="l"/>
             <a:r>
-              <a:rPr sz="1400" b="1">
-                <a:solidFill>
-                  <a:srgbClr val="1A202C"/>
+              <a:rPr sz="1200" b="1">
+                <a:solidFill>
+                  <a:srgbClr val="FFFFFF"/>
                 </a:solidFill>
                 <a:latin typeface="Calibri"/>
               </a:rPr>
-              <a:t>Blind, swapped, cross-checked judge (R5/R6)</a:t>
+              <a:t>VERIFIER</a:t>
             </a:r>
           </a:p>
         </p:txBody>
@@ -4378,8 +3760,8 @@
         </p:nvSpPr>
         <p:spPr>
           <a:xfrm>
-            <a:off x="5010912" y="1600200"/>
-            <a:ext cx="3447288" cy="960120"/>
+            <a:off x="3520440" y="1645920"/>
+            <a:ext cx="2103120" cy="731520"/>
           </a:xfrm>
           <a:prstGeom prst="rect">
             <a:avLst/>
@@ -4394,13 +3776,13 @@
           <a:p>
             <a:pPr algn="l"/>
             <a:r>
-              <a:rPr sz="1100" b="0">
+              <a:rPr sz="1000" b="0">
                 <a:solidFill>
                   <a:srgbClr val="2D3748"/>
                 </a:solidFill>
                 <a:latin typeface="Calibri"/>
               </a:rPr>
-              <a:t>Evidence blinded and reduced to the bare domain, each pair judged twice with arms swapped at temperature 0. A second model family re-rates a seeded subsample.</a:t>
+              <a:t>Independent search, prompted to disprove. Returns pass / fail with counter-evidence.</a:t>
             </a:r>
           </a:p>
         </p:txBody>
@@ -4413,8 +3795,8 @@
         </p:nvSpPr>
         <p:spPr>
           <a:xfrm>
-            <a:off x="457200" y="2743200"/>
-            <a:ext cx="4069080" cy="1463040"/>
+            <a:off x="6217920" y="1188720"/>
+            <a:ext cx="2468880" cy="1280160"/>
           </a:xfrm>
           <a:prstGeom prst="rect">
             <a:avLst/>
@@ -4458,14 +3840,14 @@
         </p:nvSpPr>
         <p:spPr>
           <a:xfrm>
-            <a:off x="457200" y="2743200"/>
-            <a:ext cx="73152" cy="1463040"/>
+            <a:off x="6217920" y="1188720"/>
+            <a:ext cx="2468880" cy="320040"/>
           </a:xfrm>
           <a:prstGeom prst="rect">
             <a:avLst/>
           </a:prstGeom>
           <a:solidFill>
-            <a:srgbClr val="0F766E"/>
+            <a:srgbClr val="C53030"/>
           </a:solidFill>
           <a:ln>
             <a:noFill/>
@@ -4501,8 +3883,8 @@
         </p:nvSpPr>
         <p:spPr>
           <a:xfrm>
-            <a:off x="850392" y="2880360"/>
-            <a:ext cx="3447288" cy="320040"/>
+            <a:off x="6400800" y="1234440"/>
+            <a:ext cx="2103120" cy="246888"/>
           </a:xfrm>
           <a:prstGeom prst="rect">
             <a:avLst/>
@@ -4517,13 +3899,13 @@
           <a:p>
             <a:pPr algn="l"/>
             <a:r>
-              <a:rPr sz="1400" b="1">
-                <a:solidFill>
-                  <a:srgbClr val="1A202C"/>
+              <a:rPr sz="1200" b="1">
+                <a:solidFill>
+                  <a:srgbClr val="FFFFFF"/>
                 </a:solidFill>
                 <a:latin typeface="Calibri"/>
               </a:rPr>
-              <a:t>Deny-list, equal and pre-fetch (R10 / D24)</a:t>
+              <a:t>ADJUDICATOR</a:t>
             </a:r>
           </a:p>
         </p:txBody>
@@ -4536,8 +3918,8 @@
         </p:nvSpPr>
         <p:spPr>
           <a:xfrm>
-            <a:off x="850392" y="3200400"/>
-            <a:ext cx="3447288" cy="960120"/>
+            <a:off x="6400800" y="1645920"/>
+            <a:ext cx="2103120" cy="731520"/>
           </a:xfrm>
           <a:prstGeom prst="rect">
             <a:avLst/>
@@ -4552,27 +3934,113 @@
           <a:p>
             <a:pPr algn="l"/>
             <a:r>
-              <a:rPr sz="1100" b="0">
+              <a:rPr sz="1000" b="0">
                 <a:solidFill>
                   <a:srgbClr val="2D3748"/>
                 </a:solidFill>
                 <a:latin typeface="Calibri"/>
               </a:rPr>
-              <a:t>ODMI publishes its own answers on data.europa.eu. That domain is blocked for every arm before retrieval, so no arm competes for a different set of usable sources.</a:t>
-            </a:r>
-          </a:p>
-        </p:txBody>
-      </p:sp>
-      <p:sp>
-        <p:nvSpPr>
-          <p:cNvPr id="17" name="Rectangle 16"/>
+              <a:t>Fires on retry exhaustion. Reads the full history, commits above the 0.65 floor or abstains.</a:t>
+            </a:r>
+          </a:p>
+        </p:txBody>
+      </p:sp>
+      <p:sp>
+        <p:nvSpPr>
+          <p:cNvPr id="17" name="Right Arrow 16"/>
           <p:cNvSpPr/>
           <p:nvPr/>
         </p:nvSpPr>
         <p:spPr>
           <a:xfrm>
-            <a:off x="4617720" y="2743200"/>
-            <a:ext cx="4069080" cy="1463040"/>
+            <a:off x="2971800" y="1719072"/>
+            <a:ext cx="320040" cy="219456"/>
+          </a:xfrm>
+          <a:prstGeom prst="rightArrow">
+            <a:avLst/>
+          </a:prstGeom>
+          <a:solidFill>
+            <a:srgbClr val="718096"/>
+          </a:solidFill>
+          <a:ln>
+            <a:noFill/>
+          </a:ln>
+        </p:spPr>
+        <p:style>
+          <a:lnRef idx="1">
+            <a:schemeClr val="accent1"/>
+          </a:lnRef>
+          <a:fillRef idx="3">
+            <a:schemeClr val="accent1"/>
+          </a:fillRef>
+          <a:effectRef idx="2">
+            <a:schemeClr val="accent1"/>
+          </a:effectRef>
+          <a:fontRef idx="minor">
+            <a:schemeClr val="lt1"/>
+          </a:fontRef>
+        </p:style>
+        <p:txBody>
+          <a:bodyPr rtlCol="0" anchor="ctr"/>
+          <a:lstStyle/>
+          <a:p>
+            <a:pPr algn="ctr"/>
+          </a:p>
+        </p:txBody>
+      </p:sp>
+      <p:sp>
+        <p:nvSpPr>
+          <p:cNvPr id="18" name="Right Arrow 17"/>
+          <p:cNvSpPr/>
+          <p:nvPr/>
+        </p:nvSpPr>
+        <p:spPr>
+          <a:xfrm>
+            <a:off x="5852160" y="1719072"/>
+            <a:ext cx="320040" cy="219456"/>
+          </a:xfrm>
+          <a:prstGeom prst="rightArrow">
+            <a:avLst/>
+          </a:prstGeom>
+          <a:solidFill>
+            <a:srgbClr val="718096"/>
+          </a:solidFill>
+          <a:ln>
+            <a:noFill/>
+          </a:ln>
+        </p:spPr>
+        <p:style>
+          <a:lnRef idx="1">
+            <a:schemeClr val="accent1"/>
+          </a:lnRef>
+          <a:fillRef idx="3">
+            <a:schemeClr val="accent1"/>
+          </a:fillRef>
+          <a:effectRef idx="2">
+            <a:schemeClr val="accent1"/>
+          </a:effectRef>
+          <a:fontRef idx="minor">
+            <a:schemeClr val="lt1"/>
+          </a:fontRef>
+        </p:style>
+        <p:txBody>
+          <a:bodyPr rtlCol="0" anchor="ctr"/>
+          <a:lstStyle/>
+          <a:p>
+            <a:pPr algn="ctr"/>
+          </a:p>
+        </p:txBody>
+      </p:sp>
+      <p:sp>
+        <p:nvSpPr>
+          <p:cNvPr id="19" name="Rectangle 18"/>
+          <p:cNvSpPr/>
+          <p:nvPr/>
+        </p:nvSpPr>
+        <p:spPr>
+          <a:xfrm>
+            <a:off x="457200" y="2788920"/>
+            <a:ext cx="8229600" cy="1508760"/>
           </a:xfrm>
           <a:prstGeom prst="rect">
             <a:avLst/>
@@ -4610,20 +4078,20 @@
       </p:sp>
       <p:sp>
         <p:nvSpPr>
-          <p:cNvPr id="18" name="Rectangle 17"/>
+          <p:cNvPr id="20" name="Rectangle 19"/>
           <p:cNvSpPr/>
           <p:nvPr/>
         </p:nvSpPr>
         <p:spPr>
           <a:xfrm>
-            <a:off x="4617720" y="2743200"/>
-            <a:ext cx="73152" cy="1463040"/>
+            <a:off x="457200" y="2788920"/>
+            <a:ext cx="73152" cy="1508760"/>
           </a:xfrm>
           <a:prstGeom prst="rect">
             <a:avLst/>
           </a:prstGeom>
           <a:solidFill>
-            <a:srgbClr val="C53030"/>
+            <a:srgbClr val="0D9488"/>
           </a:solidFill>
           <a:ln>
             <a:noFill/>
@@ -4653,14 +4121,14 @@
       </p:sp>
       <p:sp>
         <p:nvSpPr>
-          <p:cNvPr id="19" name="TextBox 18"/>
+          <p:cNvPr id="21" name="TextBox 20"/>
           <p:cNvSpPr txBox="1"/>
           <p:nvPr/>
         </p:nvSpPr>
         <p:spPr>
           <a:xfrm>
-            <a:off x="5010912" y="2880360"/>
-            <a:ext cx="3447288" cy="320040"/>
+            <a:off x="850392" y="2926080"/>
+            <a:ext cx="7607808" cy="320040"/>
           </a:xfrm>
           <a:prstGeom prst="rect">
             <a:avLst/>
@@ -4681,21 +4149,21 @@
                 </a:solidFill>
                 <a:latin typeface="Calibri"/>
               </a:rPr>
-              <a:t>The base-rate rule (R4) — the France lesson</a:t>
-            </a:r>
-          </a:p>
-        </p:txBody>
-      </p:sp>
-      <p:sp>
-        <p:nvSpPr>
-          <p:cNvPr id="20" name="TextBox 19"/>
+              <a:t>What is actually run, and what is not</a:t>
+            </a:r>
+          </a:p>
+        </p:txBody>
+      </p:sp>
+      <p:sp>
+        <p:nvSpPr>
+          <p:cNvPr id="22" name="TextBox 21"/>
           <p:cNvSpPr txBox="1"/>
           <p:nvPr/>
         </p:nvSpPr>
         <p:spPr>
           <a:xfrm>
-            <a:off x="5010912" y="3200400"/>
-            <a:ext cx="3447288" cy="960120"/>
+            <a:off x="850392" y="3246120"/>
+            <a:ext cx="7607808" cy="1005840"/>
           </a:xfrm>
           <a:prstGeom prst="rect">
             <a:avLst/>
@@ -4716,14 +4184,14 @@
                 </a:solidFill>
                 <a:latin typeface="Calibri"/>
               </a:rPr>
-              <a:t>France binary gold is 119 yes to 1 no, so 99% accuracy measures nothing. Balance-aware metrics, and Malta promoted to primary; France barred as a primary set.</a:t>
-            </a:r>
-          </a:p>
-        </p:txBody>
-      </p:sp>
-      <p:sp>
-        <p:nvSpPr>
-          <p:cNvPr id="21" name="TextBox 20"/>
+              <a:t>Plain Python state machine, Claude via CLIProxyAPI. Every call logs model + prompt version + raw response + cost, so an examiner replays it from logs alone. Run and adjudicated: EXP-1 (DIY vs Tavily), the Malta base-rate baseline (60/60), and the independent catalogue recompute. Everything else is pre-registered and built, gated on search and Claude quota. 222 pairs finalised, 5,148 ODMI ground-truth rows loaded.</a:t>
+            </a:r>
+          </a:p>
+        </p:txBody>
+      </p:sp>
+      <p:sp>
+        <p:nvSpPr>
+          <p:cNvPr id="23" name="TextBox 22"/>
           <p:cNvSpPr txBox="1"/>
           <p:nvPr/>
         </p:nvSpPr>
@@ -4751,7 +4219,7 @@
                 </a:solidFill>
                 <a:latin typeface="Calibri"/>
               </a:rPr>
-              <a:t>ODMI Agent Swarm  ·  Benjy Bream  ·  King's College London  ·  2 / 5</a:t>
+              <a:t>ODMI Agent Swarm  ·  Benjy Bream  ·  King's College London  ·  2 / 6</a:t>
             </a:r>
           </a:p>
         </p:txBody>
@@ -4847,7 +4315,7 @@
                 </a:solidFill>
                 <a:latin typeface="Calibri"/>
               </a:rPr>
-              <a:t>FINDINGS AND APPARATUS</a:t>
+              <a:t>IMPARTIALITY DESIGNED IN, NOT ASSERTED</a:t>
             </a:r>
           </a:p>
         </p:txBody>
@@ -4882,7 +4350,7 @@
                 </a:solidFill>
                 <a:latin typeface="Calibri"/>
               </a:rPr>
-              <a:t>Experiments: two real results, the rest queued</a:t>
+              <a:t>Keeping the evaluation honest</a:t>
             </a:r>
           </a:p>
         </p:txBody>
@@ -4896,7 +4364,7 @@
         <p:spPr>
           <a:xfrm>
             <a:off x="457200" y="1143000"/>
-            <a:ext cx="4069080" cy="1783080"/>
+            <a:ext cx="4069080" cy="1463040"/>
           </a:xfrm>
           <a:prstGeom prst="rect">
             <a:avLst/>
@@ -4941,13 +4409,13 @@
         <p:spPr>
           <a:xfrm>
             <a:off x="457200" y="1143000"/>
-            <a:ext cx="73152" cy="1783080"/>
+            <a:ext cx="73152" cy="1463040"/>
           </a:xfrm>
           <a:prstGeom prst="rect">
             <a:avLst/>
           </a:prstGeom>
           <a:solidFill>
-            <a:srgbClr val="38A169"/>
+            <a:srgbClr val="0D9488"/>
           </a:solidFill>
           <a:ln>
             <a:noFill/>
@@ -5005,7 +4473,7 @@
                 </a:solidFill>
                 <a:latin typeface="Calibri"/>
               </a:rPr>
-              <a:t>EXP-1 · DIY search beats Tavily (run)</a:t>
+              <a:t>Pre-registered before the data (R1)</a:t>
             </a:r>
           </a:p>
         </p:txBody>
@@ -5019,7 +4487,7 @@
         <p:spPr>
           <a:xfrm>
             <a:off x="850392" y="1600200"/>
-            <a:ext cx="3447288" cy="1280160"/>
+            <a:ext cx="3447288" cy="960120"/>
           </a:xfrm>
           <a:prstGeom prst="rect">
             <a:avLst/>
@@ -5040,7 +4508,7 @@
                 </a:solidFill>
                 <a:latin typeface="Calibri"/>
               </a:rPr>
-              <a:t>90 French pairs, blind position-swapped Opus judge. DIY wins 89% of the 55 decided pairs (Wilson [78, 95], p &lt; 1e-4); 93% under strict exclusion. Cross-family Mistral re-judge: Krippendorff alpha 0.648, which rebuts the same-family self-preference worry.</a:t>
+              <a:t>Each design is fixed in a dated git commit whose timestamp predates its result file. The run decides the answer, nothing else. No reverse-fitting.</a:t>
             </a:r>
           </a:p>
         </p:txBody>
@@ -5054,7 +4522,7 @@
         <p:spPr>
           <a:xfrm>
             <a:off x="4617720" y="1143000"/>
-            <a:ext cx="4069080" cy="1783080"/>
+            <a:ext cx="4069080" cy="1463040"/>
           </a:xfrm>
           <a:prstGeom prst="rect">
             <a:avLst/>
@@ -5099,7 +4567,7 @@
         <p:spPr>
           <a:xfrm>
             <a:off x="4617720" y="1143000"/>
-            <a:ext cx="73152" cy="1783080"/>
+            <a:ext cx="73152" cy="1463040"/>
           </a:xfrm>
           <a:prstGeom prst="rect">
             <a:avLst/>
@@ -5163,7 +4631,7 @@
                 </a:solidFill>
                 <a:latin typeface="Calibri"/>
               </a:rPr>
-              <a:t>Catalogue recompute · self-report ceiling (run)</a:t>
+              <a:t>Blind, swapped, cross-checked judge (R5/R6)</a:t>
             </a:r>
           </a:p>
         </p:txBody>
@@ -5177,7 +4645,7 @@
         <p:spPr>
           <a:xfrm>
             <a:off x="5010912" y="1600200"/>
-            <a:ext cx="3447288" cy="1280160"/>
+            <a:ext cx="3447288" cy="960120"/>
           </a:xfrm>
           <a:prstGeom prst="rect">
             <a:avLst/>
@@ -5198,7 +4666,7 @@
                 </a:solidFill>
                 <a:latin typeface="Calibri"/>
               </a:rPr>
-              <a:t>A deterministic DCAT-AP / SHACL tool recomputes the Quality questions independently of the deny-listed MQA. France self-reported &gt;90% licence coverage; the independent recompute reads ~38%. The self-report ceiling, made measurable.</a:t>
+              <a:t>Evidence blinded and reduced to the bare domain, each pair judged twice with arms swapped at temperature 0. A second model family re-rates a seeded subsample.</a:t>
             </a:r>
           </a:p>
         </p:txBody>
@@ -5211,8 +4679,8 @@
         </p:nvSpPr>
         <p:spPr>
           <a:xfrm>
-            <a:off x="457200" y="3154680"/>
-            <a:ext cx="8229600" cy="1188720"/>
+            <a:off x="457200" y="2743200"/>
+            <a:ext cx="4069080" cy="1463040"/>
           </a:xfrm>
           <a:prstGeom prst="rect">
             <a:avLst/>
@@ -5256,14 +4724,14 @@
         </p:nvSpPr>
         <p:spPr>
           <a:xfrm>
-            <a:off x="457200" y="3154680"/>
-            <a:ext cx="73152" cy="1188720"/>
+            <a:off x="457200" y="2743200"/>
+            <a:ext cx="73152" cy="1463040"/>
           </a:xfrm>
           <a:prstGeom prst="rect">
             <a:avLst/>
           </a:prstGeom>
           <a:solidFill>
-            <a:srgbClr val="718096"/>
+            <a:srgbClr val="0F766E"/>
           </a:solidFill>
           <a:ln>
             <a:noFill/>
@@ -5299,8 +4767,8 @@
         </p:nvSpPr>
         <p:spPr>
           <a:xfrm>
-            <a:off x="850392" y="3291840"/>
-            <a:ext cx="7607808" cy="320040"/>
+            <a:off x="850392" y="2880360"/>
+            <a:ext cx="3447288" cy="320040"/>
           </a:xfrm>
           <a:prstGeom prst="rect">
             <a:avLst/>
@@ -5321,7 +4789,7 @@
                 </a:solidFill>
                 <a:latin typeface="Calibri"/>
               </a:rPr>
-              <a:t>Pre-registered, built, gated on quota</a:t>
+              <a:t>Deny-list, equal and pre-fetch (R10 / D24)</a:t>
             </a:r>
           </a:p>
         </p:txBody>
@@ -5334,8 +4802,8 @@
         </p:nvSpPr>
         <p:spPr>
           <a:xfrm>
-            <a:off x="850392" y="3611880"/>
-            <a:ext cx="7607808" cy="685800"/>
+            <a:off x="850392" y="3200400"/>
+            <a:ext cx="3447288" cy="960120"/>
           </a:xfrm>
           <a:prstGeom prst="rect">
             <a:avLst/>
@@ -5356,21 +4824,109 @@
                 </a:solidFill>
                 <a:latin typeface="Calibri"/>
               </a:rPr>
-              <a:t>Malta baseline finalised 60/60. EXP-6 verifier-strategy discrimination · EXP-7 retry chaining (flag-gated, default off) · EXP-8/9 cost and model-variant surface · EXP-10 Malta failure audit with a free confidence-floor sweep. Code and pre-registration done; runs pending search and Claude headroom.</a:t>
-            </a:r>
-          </a:p>
-        </p:txBody>
-      </p:sp>
-      <p:sp>
-        <p:nvSpPr>
-          <p:cNvPr id="17" name="TextBox 16"/>
+              <a:t>ODMI publishes its own answers on data.europa.eu. That domain is blocked for every arm before retrieval, so no arm competes for a different set of usable sources.</a:t>
+            </a:r>
+          </a:p>
+        </p:txBody>
+      </p:sp>
+      <p:sp>
+        <p:nvSpPr>
+          <p:cNvPr id="17" name="Rectangle 16"/>
+          <p:cNvSpPr/>
+          <p:nvPr/>
+        </p:nvSpPr>
+        <p:spPr>
+          <a:xfrm>
+            <a:off x="4617720" y="2743200"/>
+            <a:ext cx="4069080" cy="1463040"/>
+          </a:xfrm>
+          <a:prstGeom prst="rect">
+            <a:avLst/>
+          </a:prstGeom>
+          <a:solidFill>
+            <a:srgbClr val="FFFFFF"/>
+          </a:solidFill>
+          <a:ln w="6350">
+            <a:solidFill>
+              <a:srgbClr val="E2E8F0"/>
+            </a:solidFill>
+          </a:ln>
+        </p:spPr>
+        <p:style>
+          <a:lnRef idx="1">
+            <a:schemeClr val="accent1"/>
+          </a:lnRef>
+          <a:fillRef idx="3">
+            <a:schemeClr val="accent1"/>
+          </a:fillRef>
+          <a:effectRef idx="2">
+            <a:schemeClr val="accent1"/>
+          </a:effectRef>
+          <a:fontRef idx="minor">
+            <a:schemeClr val="lt1"/>
+          </a:fontRef>
+        </p:style>
+        <p:txBody>
+          <a:bodyPr rtlCol="0" anchor="ctr"/>
+          <a:lstStyle/>
+          <a:p>
+            <a:pPr algn="ctr"/>
+          </a:p>
+        </p:txBody>
+      </p:sp>
+      <p:sp>
+        <p:nvSpPr>
+          <p:cNvPr id="18" name="Rectangle 17"/>
+          <p:cNvSpPr/>
+          <p:nvPr/>
+        </p:nvSpPr>
+        <p:spPr>
+          <a:xfrm>
+            <a:off x="4617720" y="2743200"/>
+            <a:ext cx="73152" cy="1463040"/>
+          </a:xfrm>
+          <a:prstGeom prst="rect">
+            <a:avLst/>
+          </a:prstGeom>
+          <a:solidFill>
+            <a:srgbClr val="C53030"/>
+          </a:solidFill>
+          <a:ln>
+            <a:noFill/>
+          </a:ln>
+        </p:spPr>
+        <p:style>
+          <a:lnRef idx="1">
+            <a:schemeClr val="accent1"/>
+          </a:lnRef>
+          <a:fillRef idx="3">
+            <a:schemeClr val="accent1"/>
+          </a:fillRef>
+          <a:effectRef idx="2">
+            <a:schemeClr val="accent1"/>
+          </a:effectRef>
+          <a:fontRef idx="minor">
+            <a:schemeClr val="lt1"/>
+          </a:fontRef>
+        </p:style>
+        <p:txBody>
+          <a:bodyPr rtlCol="0" anchor="ctr"/>
+          <a:lstStyle/>
+          <a:p>
+            <a:pPr algn="ctr"/>
+          </a:p>
+        </p:txBody>
+      </p:sp>
+      <p:sp>
+        <p:nvSpPr>
+          <p:cNvPr id="19" name="TextBox 18"/>
           <p:cNvSpPr txBox="1"/>
           <p:nvPr/>
         </p:nvSpPr>
         <p:spPr>
           <a:xfrm>
-            <a:off x="457200" y="4850892"/>
-            <a:ext cx="8229600" cy="182880"/>
+            <a:off x="5010912" y="2880360"/>
+            <a:ext cx="3447288" cy="320040"/>
           </a:xfrm>
           <a:prstGeom prst="rect">
             <a:avLst/>
@@ -5385,13 +4941,83 @@
           <a:p>
             <a:pPr algn="l"/>
             <a:r>
-              <a:rPr sz="800" b="0">
-                <a:solidFill>
-                  <a:srgbClr val="718096"/>
+              <a:rPr sz="1400" b="1">
+                <a:solidFill>
+                  <a:srgbClr val="1A202C"/>
                 </a:solidFill>
                 <a:latin typeface="Calibri"/>
               </a:rPr>
-              <a:t>ODMI Agent Swarm  ·  Benjy Bream  ·  King's College London  ·  3 / 5</a:t>
+              <a:t>The base-rate rule (R4) — the France lesson</a:t>
+            </a:r>
+          </a:p>
+        </p:txBody>
+      </p:sp>
+      <p:sp>
+        <p:nvSpPr>
+          <p:cNvPr id="20" name="TextBox 19"/>
+          <p:cNvSpPr txBox="1"/>
+          <p:nvPr/>
+        </p:nvSpPr>
+        <p:spPr>
+          <a:xfrm>
+            <a:off x="5010912" y="3200400"/>
+            <a:ext cx="3447288" cy="960120"/>
+          </a:xfrm>
+          <a:prstGeom prst="rect">
+            <a:avLst/>
+          </a:prstGeom>
+          <a:noFill/>
+        </p:spPr>
+        <p:txBody>
+          <a:bodyPr wrap="square" lIns="0" rIns="0" tIns="0" bIns="0">
+            <a:spAutoFit/>
+          </a:bodyPr>
+          <a:lstStyle/>
+          <a:p>
+            <a:pPr algn="l"/>
+            <a:r>
+              <a:rPr sz="1100" b="0">
+                <a:solidFill>
+                  <a:srgbClr val="2D3748"/>
+                </a:solidFill>
+                <a:latin typeface="Calibri"/>
+              </a:rPr>
+              <a:t>France binary gold is 119 yes to 1 no, so 99% accuracy measures nothing. Balance-aware metrics, and Malta promoted to primary; France barred as a primary set.</a:t>
+            </a:r>
+          </a:p>
+        </p:txBody>
+      </p:sp>
+      <p:sp>
+        <p:nvSpPr>
+          <p:cNvPr id="21" name="TextBox 20"/>
+          <p:cNvSpPr txBox="1"/>
+          <p:nvPr/>
+        </p:nvSpPr>
+        <p:spPr>
+          <a:xfrm>
+            <a:off x="457200" y="4850892"/>
+            <a:ext cx="8229600" cy="182880"/>
+          </a:xfrm>
+          <a:prstGeom prst="rect">
+            <a:avLst/>
+          </a:prstGeom>
+          <a:noFill/>
+        </p:spPr>
+        <p:txBody>
+          <a:bodyPr wrap="square" lIns="0" rIns="0" tIns="0" bIns="0">
+            <a:spAutoFit/>
+          </a:bodyPr>
+          <a:lstStyle/>
+          <a:p>
+            <a:pPr algn="l"/>
+            <a:r>
+              <a:rPr sz="800" b="0">
+                <a:solidFill>
+                  <a:srgbClr val="718096"/>
+                </a:solidFill>
+                <a:latin typeface="Calibri"/>
+              </a:rPr>
+              <a:t>ODMI Agent Swarm  ·  Benjy Bream  ·  King's College London  ·  3 / 6</a:t>
             </a:r>
           </a:p>
         </p:txBody>
@@ -5487,7 +5113,7 @@
                 </a:solidFill>
                 <a:latin typeface="Calibri"/>
               </a:rPr>
-              <a:t>WHAT BROKE, WHAT REMAINS</a:t>
+              <a:t>FINDINGS AND APPARATUS</a:t>
             </a:r>
           </a:p>
         </p:txBody>
@@ -5522,7 +5148,7 @@
                 </a:solidFill>
                 <a:latin typeface="Calibri"/>
               </a:rPr>
-              <a:t>Failure modes — fixed and still open</a:t>
+              <a:t>Experiments: two real results, the rest queued</a:t>
             </a:r>
           </a:p>
         </p:txBody>
@@ -5536,13 +5162,13 @@
         <p:spPr>
           <a:xfrm>
             <a:off x="457200" y="1143000"/>
-            <a:ext cx="4069080" cy="3246120"/>
+            <a:ext cx="4069080" cy="1783080"/>
           </a:xfrm>
           <a:prstGeom prst="rect">
             <a:avLst/>
           </a:prstGeom>
           <a:solidFill>
-            <a:srgbClr val="F7FAFC"/>
+            <a:srgbClr val="FFFFFF"/>
           </a:solidFill>
           <a:ln w="6350">
             <a:solidFill>
@@ -5581,155 +5207,7 @@
         <p:spPr>
           <a:xfrm>
             <a:off x="457200" y="1143000"/>
-            <a:ext cx="4069080" cy="411480"/>
-          </a:xfrm>
-          <a:prstGeom prst="rect">
-            <a:avLst/>
-          </a:prstGeom>
-          <a:solidFill>
-            <a:srgbClr val="0F766E"/>
-          </a:solidFill>
-          <a:ln>
-            <a:noFill/>
-          </a:ln>
-        </p:spPr>
-        <p:style>
-          <a:lnRef idx="1">
-            <a:schemeClr val="accent1"/>
-          </a:lnRef>
-          <a:fillRef idx="3">
-            <a:schemeClr val="accent1"/>
-          </a:fillRef>
-          <a:effectRef idx="2">
-            <a:schemeClr val="accent1"/>
-          </a:effectRef>
-          <a:fontRef idx="minor">
-            <a:schemeClr val="lt1"/>
-          </a:fontRef>
-        </p:style>
-        <p:txBody>
-          <a:bodyPr rtlCol="0" anchor="ctr"/>
-          <a:lstStyle/>
-          <a:p>
-            <a:pPr algn="ctr"/>
-          </a:p>
-        </p:txBody>
-      </p:sp>
-      <p:sp>
-        <p:nvSpPr>
-          <p:cNvPr id="7" name="TextBox 6"/>
-          <p:cNvSpPr txBox="1"/>
-          <p:nvPr/>
-        </p:nvSpPr>
-        <p:spPr>
-          <a:xfrm>
-            <a:off x="685800" y="1234440"/>
-            <a:ext cx="3611880" cy="274320"/>
-          </a:xfrm>
-          <a:prstGeom prst="rect">
-            <a:avLst/>
-          </a:prstGeom>
-          <a:noFill/>
-        </p:spPr>
-        <p:txBody>
-          <a:bodyPr wrap="square" lIns="0" rIns="0" tIns="0" bIns="0">
-            <a:spAutoFit/>
-          </a:bodyPr>
-          <a:lstStyle/>
-          <a:p>
-            <a:pPr algn="l"/>
-            <a:r>
-              <a:rPr sz="1100" b="1">
-                <a:solidFill>
-                  <a:srgbClr val="FFFFFF"/>
-                </a:solidFill>
-                <a:latin typeface="Calibri"/>
-              </a:rPr>
-              <a:t>FIXED</a:t>
-            </a:r>
-          </a:p>
-        </p:txBody>
-      </p:sp>
-      <p:sp>
-        <p:nvSpPr>
-          <p:cNvPr id="8" name="TextBox 7"/>
-          <p:cNvSpPr txBox="1"/>
-          <p:nvPr/>
-        </p:nvSpPr>
-        <p:spPr>
-          <a:xfrm>
-            <a:off x="1051560" y="1645920"/>
-            <a:ext cx="3429000" cy="256032"/>
-          </a:xfrm>
-          <a:prstGeom prst="rect">
-            <a:avLst/>
-          </a:prstGeom>
-          <a:noFill/>
-        </p:spPr>
-        <p:txBody>
-          <a:bodyPr wrap="square" lIns="0" rIns="0" tIns="0" bIns="0">
-            <a:spAutoFit/>
-          </a:bodyPr>
-          <a:lstStyle/>
-          <a:p>
-            <a:pPr algn="l"/>
-            <a:r>
-              <a:rPr sz="1100" b="1">
-                <a:solidFill>
-                  <a:srgbClr val="1A202C"/>
-                </a:solidFill>
-                <a:latin typeface="Calibri"/>
-              </a:rPr>
-              <a:t>WAF 403 on data.gov.mt</a:t>
-            </a:r>
-          </a:p>
-        </p:txBody>
-      </p:sp>
-      <p:sp>
-        <p:nvSpPr>
-          <p:cNvPr id="9" name="TextBox 8"/>
-          <p:cNvSpPr txBox="1"/>
-          <p:nvPr/>
-        </p:nvSpPr>
-        <p:spPr>
-          <a:xfrm>
-            <a:off x="1051560" y="1901952"/>
-            <a:ext cx="3429000" cy="591312"/>
-          </a:xfrm>
-          <a:prstGeom prst="rect">
-            <a:avLst/>
-          </a:prstGeom>
-          <a:noFill/>
-        </p:spPr>
-        <p:txBody>
-          <a:bodyPr wrap="square" lIns="0" rIns="0" tIns="0" bIns="0">
-            <a:spAutoFit/>
-          </a:bodyPr>
-          <a:lstStyle/>
-          <a:p>
-            <a:pPr algn="l"/>
-            <a:r>
-              <a:rPr sz="1000" b="0">
-                <a:solidFill>
-                  <a:srgbClr val="2D3748"/>
-                </a:solidFill>
-                <a:latin typeface="Calibri"/>
-              </a:rPr>
-              <a:t>Cloudflare blocked head checks and killed valid answers. A Playwright render now retries on 403 / 429 / 503.</a:t>
-            </a:r>
-          </a:p>
-        </p:txBody>
-      </p:sp>
-      <p:sp>
-        <p:nvSpPr>
-          <p:cNvPr id="10" name="Rectangle 9"/>
-          <p:cNvSpPr/>
-          <p:nvPr/>
-        </p:nvSpPr>
-        <p:spPr>
-          <a:xfrm>
-            <a:off x="640080" y="1719072"/>
-            <a:ext cx="164592" cy="164592"/>
+            <a:ext cx="73152" cy="1783080"/>
           </a:xfrm>
           <a:prstGeom prst="rect">
             <a:avLst/>
@@ -5765,14 +5243,14 @@
       </p:sp>
       <p:sp>
         <p:nvSpPr>
-          <p:cNvPr id="11" name="TextBox 10"/>
+          <p:cNvPr id="7" name="TextBox 6"/>
           <p:cNvSpPr txBox="1"/>
           <p:nvPr/>
         </p:nvSpPr>
         <p:spPr>
           <a:xfrm>
-            <a:off x="1051560" y="2529840"/>
-            <a:ext cx="3429000" cy="256032"/>
+            <a:off x="850392" y="1280160"/>
+            <a:ext cx="3447288" cy="320040"/>
           </a:xfrm>
           <a:prstGeom prst="rect">
             <a:avLst/>
@@ -5787,27 +5265,27 @@
           <a:p>
             <a:pPr algn="l"/>
             <a:r>
-              <a:rPr sz="1100" b="1">
+              <a:rPr sz="1400" b="1">
                 <a:solidFill>
                   <a:srgbClr val="1A202C"/>
                 </a:solidFill>
                 <a:latin typeface="Calibri"/>
               </a:rPr>
-              <a:t>Resume stranded pairs</a:t>
-            </a:r>
-          </a:p>
-        </p:txBody>
-      </p:sp>
-      <p:sp>
-        <p:nvSpPr>
-          <p:cNvPr id="12" name="TextBox 11"/>
+              <a:t>EXP-1 · DIY search beats Tavily (run)</a:t>
+            </a:r>
+          </a:p>
+        </p:txBody>
+      </p:sp>
+      <p:sp>
+        <p:nvSpPr>
+          <p:cNvPr id="8" name="TextBox 7"/>
           <p:cNvSpPr txBox="1"/>
           <p:nvPr/>
         </p:nvSpPr>
         <p:spPr>
           <a:xfrm>
-            <a:off x="1051560" y="2785872"/>
-            <a:ext cx="3429000" cy="591312"/>
+            <a:off x="850392" y="1600200"/>
+            <a:ext cx="3447288" cy="1280160"/>
           </a:xfrm>
           <a:prstGeom prst="rect">
             <a:avLst/>
@@ -5822,189 +5300,33 @@
           <a:p>
             <a:pPr algn="l"/>
             <a:r>
-              <a:rPr sz="1000" b="0">
+              <a:rPr sz="1100" b="0">
                 <a:solidFill>
                   <a:srgbClr val="2D3748"/>
                 </a:solidFill>
                 <a:latin typeface="Calibri"/>
               </a:rPr>
-              <a:t>The resume path reused failed Researcher rows, leaving 11 pairs stuck at 'researching'. Fixed in the coordinator.</a:t>
-            </a:r>
-          </a:p>
-        </p:txBody>
-      </p:sp>
-      <p:sp>
-        <p:nvSpPr>
-          <p:cNvPr id="13" name="Rectangle 12"/>
+              <a:t>90 French pairs, blind position-swapped Opus judge. DIY wins 89% of the 55 decided pairs (Wilson [78, 95], p &lt; 1e-4); 93% under strict exclusion. Cross-family Mistral re-judge: Krippendorff alpha 0.648, which rebuts the same-family self-preference worry.</a:t>
+            </a:r>
+          </a:p>
+        </p:txBody>
+      </p:sp>
+      <p:sp>
+        <p:nvSpPr>
+          <p:cNvPr id="9" name="Rectangle 8"/>
           <p:cNvSpPr/>
           <p:nvPr/>
         </p:nvSpPr>
         <p:spPr>
           <a:xfrm>
-            <a:off x="640080" y="2602992"/>
-            <a:ext cx="164592" cy="164592"/>
+            <a:off x="4617720" y="1143000"/>
+            <a:ext cx="4069080" cy="1783080"/>
           </a:xfrm>
           <a:prstGeom prst="rect">
             <a:avLst/>
           </a:prstGeom>
           <a:solidFill>
-            <a:srgbClr val="38A169"/>
-          </a:solidFill>
-          <a:ln>
-            <a:noFill/>
-          </a:ln>
-        </p:spPr>
-        <p:style>
-          <a:lnRef idx="1">
-            <a:schemeClr val="accent1"/>
-          </a:lnRef>
-          <a:fillRef idx="3">
-            <a:schemeClr val="accent1"/>
-          </a:fillRef>
-          <a:effectRef idx="2">
-            <a:schemeClr val="accent1"/>
-          </a:effectRef>
-          <a:fontRef idx="minor">
-            <a:schemeClr val="lt1"/>
-          </a:fontRef>
-        </p:style>
-        <p:txBody>
-          <a:bodyPr rtlCol="0" anchor="ctr"/>
-          <a:lstStyle/>
-          <a:p>
-            <a:pPr algn="ctr"/>
-          </a:p>
-        </p:txBody>
-      </p:sp>
-      <p:sp>
-        <p:nvSpPr>
-          <p:cNvPr id="14" name="TextBox 13"/>
-          <p:cNvSpPr txBox="1"/>
-          <p:nvPr/>
-        </p:nvSpPr>
-        <p:spPr>
-          <a:xfrm>
-            <a:off x="1051560" y="3413760"/>
-            <a:ext cx="3429000" cy="256032"/>
-          </a:xfrm>
-          <a:prstGeom prst="rect">
-            <a:avLst/>
-          </a:prstGeom>
-          <a:noFill/>
-        </p:spPr>
-        <p:txBody>
-          <a:bodyPr wrap="square" lIns="0" rIns="0" tIns="0" bIns="0">
-            <a:spAutoFit/>
-          </a:bodyPr>
-          <a:lstStyle/>
-          <a:p>
-            <a:pPr algn="l"/>
-            <a:r>
-              <a:rPr sz="1100" b="1">
-                <a:solidFill>
-                  <a:srgbClr val="1A202C"/>
-                </a:solidFill>
-                <a:latin typeface="Calibri"/>
-              </a:rPr>
-              <a:t>Silent auth failure</a:t>
-            </a:r>
-          </a:p>
-        </p:txBody>
-      </p:sp>
-      <p:sp>
-        <p:nvSpPr>
-          <p:cNvPr id="15" name="TextBox 14"/>
-          <p:cNvSpPr txBox="1"/>
-          <p:nvPr/>
-        </p:nvSpPr>
-        <p:spPr>
-          <a:xfrm>
-            <a:off x="1051560" y="3669792"/>
-            <a:ext cx="3429000" cy="591312"/>
-          </a:xfrm>
-          <a:prstGeom prst="rect">
-            <a:avLst/>
-          </a:prstGeom>
-          <a:noFill/>
-        </p:spPr>
-        <p:txBody>
-          <a:bodyPr wrap="square" lIns="0" rIns="0" tIns="0" bIns="0">
-            <a:spAutoFit/>
-          </a:bodyPr>
-          <a:lstStyle/>
-          <a:p>
-            <a:pPr algn="l"/>
-            <a:r>
-              <a:rPr sz="1000" b="0">
-                <a:solidFill>
-                  <a:srgbClr val="2D3748"/>
-                </a:solidFill>
-                <a:latin typeface="Calibri"/>
-              </a:rPr>
-              <a:t>An empty auth token made every call fail as a misleading connection error. Fixed in the LLM client.</a:t>
-            </a:r>
-          </a:p>
-        </p:txBody>
-      </p:sp>
-      <p:sp>
-        <p:nvSpPr>
-          <p:cNvPr id="16" name="Rectangle 15"/>
-          <p:cNvSpPr/>
-          <p:nvPr/>
-        </p:nvSpPr>
-        <p:spPr>
-          <a:xfrm>
-            <a:off x="640080" y="3486912"/>
-            <a:ext cx="164592" cy="164592"/>
-          </a:xfrm>
-          <a:prstGeom prst="rect">
-            <a:avLst/>
-          </a:prstGeom>
-          <a:solidFill>
-            <a:srgbClr val="38A169"/>
-          </a:solidFill>
-          <a:ln>
-            <a:noFill/>
-          </a:ln>
-        </p:spPr>
-        <p:style>
-          <a:lnRef idx="1">
-            <a:schemeClr val="accent1"/>
-          </a:lnRef>
-          <a:fillRef idx="3">
-            <a:schemeClr val="accent1"/>
-          </a:fillRef>
-          <a:effectRef idx="2">
-            <a:schemeClr val="accent1"/>
-          </a:effectRef>
-          <a:fontRef idx="minor">
-            <a:schemeClr val="lt1"/>
-          </a:fontRef>
-        </p:style>
-        <p:txBody>
-          <a:bodyPr rtlCol="0" anchor="ctr"/>
-          <a:lstStyle/>
-          <a:p>
-            <a:pPr algn="ctr"/>
-          </a:p>
-        </p:txBody>
-      </p:sp>
-      <p:sp>
-        <p:nvSpPr>
-          <p:cNvPr id="17" name="Rectangle 16"/>
-          <p:cNvSpPr/>
-          <p:nvPr/>
-        </p:nvSpPr>
-        <p:spPr>
-          <a:xfrm>
-            <a:off x="4617720" y="1143000"/>
-            <a:ext cx="4069080" cy="3246120"/>
-          </a:xfrm>
-          <a:prstGeom prst="rect">
-            <a:avLst/>
-          </a:prstGeom>
-          <a:solidFill>
-            <a:srgbClr val="F7FAFC"/>
+            <a:srgbClr val="FFFFFF"/>
           </a:solidFill>
           <a:ln w="6350">
             <a:solidFill>
@@ -6036,20 +5358,20 @@
       </p:sp>
       <p:sp>
         <p:nvSpPr>
-          <p:cNvPr id="18" name="Rectangle 17"/>
+          <p:cNvPr id="10" name="Rectangle 9"/>
           <p:cNvSpPr/>
           <p:nvPr/>
         </p:nvSpPr>
         <p:spPr>
           <a:xfrm>
             <a:off x="4617720" y="1143000"/>
-            <a:ext cx="4069080" cy="411480"/>
+            <a:ext cx="73152" cy="1783080"/>
           </a:xfrm>
           <a:prstGeom prst="rect">
             <a:avLst/>
           </a:prstGeom>
           <a:solidFill>
-            <a:srgbClr val="D69E2E"/>
+            <a:srgbClr val="1E3A5F"/>
           </a:solidFill>
           <a:ln>
             <a:noFill/>
@@ -6079,14 +5401,14 @@
       </p:sp>
       <p:sp>
         <p:nvSpPr>
-          <p:cNvPr id="19" name="TextBox 18"/>
+          <p:cNvPr id="11" name="TextBox 10"/>
           <p:cNvSpPr txBox="1"/>
           <p:nvPr/>
         </p:nvSpPr>
         <p:spPr>
           <a:xfrm>
-            <a:off x="4846320" y="1234440"/>
-            <a:ext cx="3611880" cy="274320"/>
+            <a:off x="5010912" y="1280160"/>
+            <a:ext cx="3447288" cy="320040"/>
           </a:xfrm>
           <a:prstGeom prst="rect">
             <a:avLst/>
@@ -6101,27 +5423,27 @@
           <a:p>
             <a:pPr algn="l"/>
             <a:r>
-              <a:rPr sz="1100" b="1">
-                <a:solidFill>
-                  <a:srgbClr val="FFFFFF"/>
+              <a:rPr sz="1400" b="1">
+                <a:solidFill>
+                  <a:srgbClr val="1A202C"/>
                 </a:solidFill>
                 <a:latin typeface="Calibri"/>
               </a:rPr>
-              <a:t>STILL OPEN</a:t>
-            </a:r>
-          </a:p>
-        </p:txBody>
-      </p:sp>
-      <p:sp>
-        <p:nvSpPr>
-          <p:cNvPr id="20" name="TextBox 19"/>
+              <a:t>Catalogue recompute · self-report ceiling (run)</a:t>
+            </a:r>
+          </a:p>
+        </p:txBody>
+      </p:sp>
+      <p:sp>
+        <p:nvSpPr>
+          <p:cNvPr id="12" name="TextBox 11"/>
           <p:cNvSpPr txBox="1"/>
           <p:nvPr/>
         </p:nvSpPr>
         <p:spPr>
           <a:xfrm>
-            <a:off x="5212080" y="1645920"/>
-            <a:ext cx="3429000" cy="256032"/>
+            <a:off x="5010912" y="1600200"/>
+            <a:ext cx="3447288" cy="1280160"/>
           </a:xfrm>
           <a:prstGeom prst="rect">
             <a:avLst/>
@@ -6136,71 +5458,38 @@
           <a:p>
             <a:pPr algn="l"/>
             <a:r>
-              <a:rPr sz="1100" b="1">
-                <a:solidFill>
-                  <a:srgbClr val="1A202C"/>
+              <a:rPr sz="1100" b="0">
+                <a:solidFill>
+                  <a:srgbClr val="2D3748"/>
                 </a:solidFill>
                 <a:latin typeface="Calibri"/>
               </a:rPr>
-              <a:t>Retrieval ceiling</a:t>
-            </a:r>
-          </a:p>
-        </p:txBody>
-      </p:sp>
-      <p:sp>
-        <p:nvSpPr>
-          <p:cNvPr id="21" name="TextBox 20"/>
-          <p:cNvSpPr txBox="1"/>
-          <p:nvPr/>
-        </p:nvSpPr>
-        <p:spPr>
-          <a:xfrm>
-            <a:off x="5212080" y="1901952"/>
-            <a:ext cx="3429000" cy="591312"/>
-          </a:xfrm>
-          <a:prstGeom prst="rect">
-            <a:avLst/>
-          </a:prstGeom>
-          <a:noFill/>
-        </p:spPr>
-        <p:txBody>
-          <a:bodyPr wrap="square" lIns="0" rIns="0" tIns="0" bIns="0">
-            <a:spAutoFit/>
-          </a:bodyPr>
-          <a:lstStyle/>
-          <a:p>
-            <a:pPr algn="l"/>
-            <a:r>
-              <a:rPr sz="1000" b="0">
-                <a:solidFill>
-                  <a:srgbClr val="2D3748"/>
-                </a:solidFill>
-                <a:latin typeface="Calibri"/>
-              </a:rPr>
-              <a:t>Self-report and deny-listed Quality questions are not answerable from the open web. The residual bottleneck.</a:t>
-            </a:r>
-          </a:p>
-        </p:txBody>
-      </p:sp>
-      <p:sp>
-        <p:nvSpPr>
-          <p:cNvPr id="22" name="Rectangle 21"/>
+              <a:t>A deterministic DCAT-AP / SHACL tool recomputes the Quality questions independently of the deny-listed MQA. France self-reported &gt;90% licence coverage; the independent recompute reads ~38%. The self-report ceiling, made measurable.</a:t>
+            </a:r>
+          </a:p>
+        </p:txBody>
+      </p:sp>
+      <p:sp>
+        <p:nvSpPr>
+          <p:cNvPr id="13" name="Rectangle 12"/>
           <p:cNvSpPr/>
           <p:nvPr/>
         </p:nvSpPr>
         <p:spPr>
           <a:xfrm>
-            <a:off x="4800600" y="1719072"/>
-            <a:ext cx="164592" cy="164592"/>
+            <a:off x="457200" y="3154680"/>
+            <a:ext cx="8229600" cy="1188720"/>
           </a:xfrm>
           <a:prstGeom prst="rect">
             <a:avLst/>
           </a:prstGeom>
           <a:solidFill>
-            <a:srgbClr val="D69E2E"/>
+            <a:srgbClr val="FFFFFF"/>
           </a:solidFill>
-          <a:ln>
-            <a:noFill/>
+          <a:ln w="6350">
+            <a:solidFill>
+              <a:srgbClr val="E2E8F0"/>
+            </a:solidFill>
           </a:ln>
         </p:spPr>
         <p:style>
@@ -6227,90 +5516,20 @@
       </p:sp>
       <p:sp>
         <p:nvSpPr>
-          <p:cNvPr id="23" name="TextBox 22"/>
-          <p:cNvSpPr txBox="1"/>
-          <p:nvPr/>
-        </p:nvSpPr>
-        <p:spPr>
-          <a:xfrm>
-            <a:off x="5212080" y="2529840"/>
-            <a:ext cx="3429000" cy="256032"/>
-          </a:xfrm>
-          <a:prstGeom prst="rect">
-            <a:avLst/>
-          </a:prstGeom>
-          <a:noFill/>
-        </p:spPr>
-        <p:txBody>
-          <a:bodyPr wrap="square" lIns="0" rIns="0" tIns="0" bIns="0">
-            <a:spAutoFit/>
-          </a:bodyPr>
-          <a:lstStyle/>
-          <a:p>
-            <a:pPr algn="l"/>
-            <a:r>
-              <a:rPr sz="1100" b="1">
-                <a:solidFill>
-                  <a:srgbClr val="1A202C"/>
-                </a:solidFill>
-                <a:latin typeface="Calibri"/>
-              </a:rPr>
-              <a:t>Recall asymmetry</a:t>
-            </a:r>
-          </a:p>
-        </p:txBody>
-      </p:sp>
-      <p:sp>
-        <p:nvSpPr>
-          <p:cNvPr id="24" name="TextBox 23"/>
-          <p:cNvSpPr txBox="1"/>
-          <p:nvPr/>
-        </p:nvSpPr>
-        <p:spPr>
-          <a:xfrm>
-            <a:off x="5212080" y="2785872"/>
-            <a:ext cx="3429000" cy="591312"/>
-          </a:xfrm>
-          <a:prstGeom prst="rect">
-            <a:avLst/>
-          </a:prstGeom>
-          <a:noFill/>
-        </p:spPr>
-        <p:txBody>
-          <a:bodyPr wrap="square" lIns="0" rIns="0" tIns="0" bIns="0">
-            <a:spAutoFit/>
-          </a:bodyPr>
-          <a:lstStyle/>
-          <a:p>
-            <a:pPr algn="l"/>
-            <a:r>
-              <a:rPr sz="1000" b="0">
-                <a:solidFill>
-                  <a:srgbClr val="2D3748"/>
-                </a:solidFill>
-                <a:latin typeface="Calibri"/>
-              </a:rPr>
-              <a:t>Yes-gold recall 0.60 against no-gold 0.87: the swarm confirms a 'no' more readily than a 'yes' on sparse evidence.</a:t>
-            </a:r>
-          </a:p>
-        </p:txBody>
-      </p:sp>
-      <p:sp>
-        <p:nvSpPr>
-          <p:cNvPr id="25" name="Rectangle 24"/>
+          <p:cNvPr id="14" name="Rectangle 13"/>
           <p:cNvSpPr/>
           <p:nvPr/>
         </p:nvSpPr>
         <p:spPr>
           <a:xfrm>
-            <a:off x="4800600" y="2602992"/>
-            <a:ext cx="164592" cy="164592"/>
+            <a:off x="457200" y="3154680"/>
+            <a:ext cx="73152" cy="1188720"/>
           </a:xfrm>
           <a:prstGeom prst="rect">
             <a:avLst/>
           </a:prstGeom>
           <a:solidFill>
-            <a:srgbClr val="D69E2E"/>
+            <a:srgbClr val="718096"/>
           </a:solidFill>
           <a:ln>
             <a:noFill/>
@@ -6340,14 +5559,14 @@
       </p:sp>
       <p:sp>
         <p:nvSpPr>
-          <p:cNvPr id="26" name="TextBox 25"/>
+          <p:cNvPr id="15" name="TextBox 14"/>
           <p:cNvSpPr txBox="1"/>
           <p:nvPr/>
         </p:nvSpPr>
         <p:spPr>
           <a:xfrm>
-            <a:off x="5212080" y="3413760"/>
-            <a:ext cx="3429000" cy="256032"/>
+            <a:off x="850392" y="3291840"/>
+            <a:ext cx="7607808" cy="320040"/>
           </a:xfrm>
           <a:prstGeom prst="rect">
             <a:avLst/>
@@ -6362,27 +5581,27 @@
           <a:p>
             <a:pPr algn="l"/>
             <a:r>
-              <a:rPr sz="1100" b="1">
+              <a:rPr sz="1400" b="1">
                 <a:solidFill>
                   <a:srgbClr val="1A202C"/>
                 </a:solidFill>
                 <a:latin typeface="Calibri"/>
               </a:rPr>
-              <a:t>Thin-web countries</a:t>
-            </a:r>
-          </a:p>
-        </p:txBody>
-      </p:sp>
-      <p:sp>
-        <p:nvSpPr>
-          <p:cNvPr id="27" name="TextBox 26"/>
+              <a:t>Pre-registered, built, gated on quota</a:t>
+            </a:r>
+          </a:p>
+        </p:txBody>
+      </p:sp>
+      <p:sp>
+        <p:nvSpPr>
+          <p:cNvPr id="16" name="TextBox 15"/>
           <p:cNvSpPr txBox="1"/>
           <p:nvPr/>
         </p:nvSpPr>
         <p:spPr>
           <a:xfrm>
-            <a:off x="5212080" y="3669792"/>
-            <a:ext cx="3429000" cy="591312"/>
+            <a:off x="850392" y="3611880"/>
+            <a:ext cx="7607808" cy="685800"/>
           </a:xfrm>
           <a:prstGeom prst="rect">
             <a:avLst/>
@@ -6397,63 +5616,20 @@
           <a:p>
             <a:pPr algn="l"/>
             <a:r>
-              <a:rPr sz="1000" b="0">
+              <a:rPr sz="1100" b="0">
                 <a:solidFill>
                   <a:srgbClr val="2D3748"/>
                 </a:solidFill>
                 <a:latin typeface="Calibri"/>
               </a:rPr>
-              <a:t>Low-resource languages and sparse results untested at scale; language and difficulty are still confounded.</a:t>
-            </a:r>
-          </a:p>
-        </p:txBody>
-      </p:sp>
-      <p:sp>
-        <p:nvSpPr>
-          <p:cNvPr id="28" name="Rectangle 27"/>
-          <p:cNvSpPr/>
-          <p:nvPr/>
-        </p:nvSpPr>
-        <p:spPr>
-          <a:xfrm>
-            <a:off x="4800600" y="3486912"/>
-            <a:ext cx="164592" cy="164592"/>
-          </a:xfrm>
-          <a:prstGeom prst="rect">
-            <a:avLst/>
-          </a:prstGeom>
-          <a:solidFill>
-            <a:srgbClr val="D69E2E"/>
-          </a:solidFill>
-          <a:ln>
-            <a:noFill/>
-          </a:ln>
-        </p:spPr>
-        <p:style>
-          <a:lnRef idx="1">
-            <a:schemeClr val="accent1"/>
-          </a:lnRef>
-          <a:fillRef idx="3">
-            <a:schemeClr val="accent1"/>
-          </a:fillRef>
-          <a:effectRef idx="2">
-            <a:schemeClr val="accent1"/>
-          </a:effectRef>
-          <a:fontRef idx="minor">
-            <a:schemeClr val="lt1"/>
-          </a:fontRef>
-        </p:style>
-        <p:txBody>
-          <a:bodyPr rtlCol="0" anchor="ctr"/>
-          <a:lstStyle/>
-          <a:p>
-            <a:pPr algn="ctr"/>
-          </a:p>
-        </p:txBody>
-      </p:sp>
-      <p:sp>
-        <p:nvSpPr>
-          <p:cNvPr id="29" name="TextBox 28"/>
+              <a:t>Malta baseline finalised 60/60. EXP-6 verifier-strategy discrimination · EXP-7 retry chaining (flag-gated, default off) · EXP-8/9 cost and model-variant surface · EXP-10 Malta failure audit with a free confidence-floor sweep. Code and pre-registration done; runs pending search and Claude headroom.</a:t>
+            </a:r>
+          </a:p>
+        </p:txBody>
+      </p:sp>
+      <p:sp>
+        <p:nvSpPr>
+          <p:cNvPr id="17" name="TextBox 16"/>
           <p:cNvSpPr txBox="1"/>
           <p:nvPr/>
         </p:nvSpPr>
@@ -6481,7 +5657,7 @@
                 </a:solidFill>
                 <a:latin typeface="Calibri"/>
               </a:rPr>
-              <a:t>ODMI Agent Swarm  ·  Benjy Bream  ·  King's College London  ·  4 / 5</a:t>
+              <a:t>ODMI Agent Swarm  ·  Benjy Bream  ·  King's College London  ·  4 / 6</a:t>
             </a:r>
           </a:p>
         </p:txBody>
@@ -6577,7 +5753,7 @@
                 </a:solidFill>
                 <a:latin typeface="Calibri"/>
               </a:rPr>
-              <a:t>NEXT STEPS AND OPEN QUESTIONS</a:t>
+              <a:t>WHAT BROKE, WHAT REMAINS</a:t>
             </a:r>
           </a:p>
         </p:txBody>
@@ -6612,7 +5788,7 @@
                 </a:solidFill>
                 <a:latin typeface="Calibri"/>
               </a:rPr>
-              <a:t>Where I want your opinion</a:t>
+              <a:t>Failure modes — fixed and still open</a:t>
             </a:r>
           </a:p>
         </p:txBody>
@@ -6677,7 +5853,7 @@
             <a:avLst/>
           </a:prstGeom>
           <a:solidFill>
-            <a:srgbClr val="1A202C"/>
+            <a:srgbClr val="0F766E"/>
           </a:solidFill>
           <a:ln>
             <a:noFill/>
@@ -6735,7 +5911,7 @@
                 </a:solidFill>
                 <a:latin typeface="Calibri"/>
               </a:rPr>
-              <a:t>NEXT STEPS</a:t>
+              <a:t>FIXED</a:t>
             </a:r>
           </a:p>
         </p:txBody>
@@ -6770,7 +5946,7 @@
                 </a:solidFill>
                 <a:latin typeface="Calibri"/>
               </a:rPr>
-              <a:t>Freeze a held-out test stratum</a:t>
+              <a:t>WAF 403 on data.gov.mt</a:t>
             </a:r>
           </a:p>
         </p:txBody>
@@ -6805,7 +5981,7 @@
                 </a:solidFill>
                 <a:latin typeface="Calibri"/>
               </a:rPr>
-              <a:t>Tune on a subset, report final accuracy on unseen countries against the contemporaneous web.</a:t>
+              <a:t>Cloudflare blocked head checks and killed valid answers. A Playwright render now retries on 403 / 429 / 503.</a:t>
             </a:r>
           </a:p>
         </p:txBody>
@@ -6825,7 +6001,7 @@
             <a:avLst/>
           </a:prstGeom>
           <a:solidFill>
-            <a:srgbClr val="0D9488"/>
+            <a:srgbClr val="38A169"/>
           </a:solidFill>
           <a:ln>
             <a:noFill/>
@@ -6883,7 +6059,7 @@
                 </a:solidFill>
                 <a:latin typeface="Calibri"/>
               </a:rPr>
-              <a:t>Run the pre-registered set</a:t>
+              <a:t>Resume stranded pairs</a:t>
             </a:r>
           </a:p>
         </p:txBody>
@@ -6918,7 +6094,7 @@
                 </a:solidFill>
                 <a:latin typeface="Calibri"/>
               </a:rPr>
-              <a:t>EXP-6 / 7 / 8 / 9 / 10 once quota resets; build the accuracy-cost surface.</a:t>
+              <a:t>The resume path reused failed Researcher rows, leaving 11 pairs stuck at 'researching'. Fixed in the coordinator.</a:t>
             </a:r>
           </a:p>
         </p:txBody>
@@ -6938,7 +6114,7 @@
             <a:avLst/>
           </a:prstGeom>
           <a:solidFill>
-            <a:srgbClr val="0D9488"/>
+            <a:srgbClr val="38A169"/>
           </a:solidFill>
           <a:ln>
             <a:noFill/>
@@ -6996,7 +6172,7 @@
                 </a:solidFill>
                 <a:latin typeface="Calibri"/>
               </a:rPr>
-              <a:t>Six-country sweep</a:t>
+              <a:t>Silent auth failure</a:t>
             </a:r>
           </a:p>
         </p:txBody>
@@ -7031,7 +6207,7 @@
                 </a:solidFill>
                 <a:latin typeface="Calibri"/>
               </a:rPr>
-              <a:t>Wealth x maturity matrix across all 143 questions, base-rate checked per cell.</a:t>
+              <a:t>An empty auth token made every call fail as a misleading connection error. Fixed in the LLM client.</a:t>
             </a:r>
           </a:p>
         </p:txBody>
@@ -7051,7 +6227,7 @@
             <a:avLst/>
           </a:prstGeom>
           <a:solidFill>
-            <a:srgbClr val="0D9488"/>
+            <a:srgbClr val="38A169"/>
           </a:solidFill>
           <a:ln>
             <a:noFill/>
@@ -7139,6 +6315,1096 @@
             <a:avLst/>
           </a:prstGeom>
           <a:solidFill>
+            <a:srgbClr val="D69E2E"/>
+          </a:solidFill>
+          <a:ln>
+            <a:noFill/>
+          </a:ln>
+        </p:spPr>
+        <p:style>
+          <a:lnRef idx="1">
+            <a:schemeClr val="accent1"/>
+          </a:lnRef>
+          <a:fillRef idx="3">
+            <a:schemeClr val="accent1"/>
+          </a:fillRef>
+          <a:effectRef idx="2">
+            <a:schemeClr val="accent1"/>
+          </a:effectRef>
+          <a:fontRef idx="minor">
+            <a:schemeClr val="lt1"/>
+          </a:fontRef>
+        </p:style>
+        <p:txBody>
+          <a:bodyPr rtlCol="0" anchor="ctr"/>
+          <a:lstStyle/>
+          <a:p>
+            <a:pPr algn="ctr"/>
+          </a:p>
+        </p:txBody>
+      </p:sp>
+      <p:sp>
+        <p:nvSpPr>
+          <p:cNvPr id="19" name="TextBox 18"/>
+          <p:cNvSpPr txBox="1"/>
+          <p:nvPr/>
+        </p:nvSpPr>
+        <p:spPr>
+          <a:xfrm>
+            <a:off x="4846320" y="1234440"/>
+            <a:ext cx="3611880" cy="274320"/>
+          </a:xfrm>
+          <a:prstGeom prst="rect">
+            <a:avLst/>
+          </a:prstGeom>
+          <a:noFill/>
+        </p:spPr>
+        <p:txBody>
+          <a:bodyPr wrap="square" lIns="0" rIns="0" tIns="0" bIns="0">
+            <a:spAutoFit/>
+          </a:bodyPr>
+          <a:lstStyle/>
+          <a:p>
+            <a:pPr algn="l"/>
+            <a:r>
+              <a:rPr sz="1100" b="1">
+                <a:solidFill>
+                  <a:srgbClr val="FFFFFF"/>
+                </a:solidFill>
+                <a:latin typeface="Calibri"/>
+              </a:rPr>
+              <a:t>STILL OPEN</a:t>
+            </a:r>
+          </a:p>
+        </p:txBody>
+      </p:sp>
+      <p:sp>
+        <p:nvSpPr>
+          <p:cNvPr id="20" name="TextBox 19"/>
+          <p:cNvSpPr txBox="1"/>
+          <p:nvPr/>
+        </p:nvSpPr>
+        <p:spPr>
+          <a:xfrm>
+            <a:off x="5212080" y="1645920"/>
+            <a:ext cx="3429000" cy="256032"/>
+          </a:xfrm>
+          <a:prstGeom prst="rect">
+            <a:avLst/>
+          </a:prstGeom>
+          <a:noFill/>
+        </p:spPr>
+        <p:txBody>
+          <a:bodyPr wrap="square" lIns="0" rIns="0" tIns="0" bIns="0">
+            <a:spAutoFit/>
+          </a:bodyPr>
+          <a:lstStyle/>
+          <a:p>
+            <a:pPr algn="l"/>
+            <a:r>
+              <a:rPr sz="1100" b="1">
+                <a:solidFill>
+                  <a:srgbClr val="1A202C"/>
+                </a:solidFill>
+                <a:latin typeface="Calibri"/>
+              </a:rPr>
+              <a:t>Retrieval ceiling</a:t>
+            </a:r>
+          </a:p>
+        </p:txBody>
+      </p:sp>
+      <p:sp>
+        <p:nvSpPr>
+          <p:cNvPr id="21" name="TextBox 20"/>
+          <p:cNvSpPr txBox="1"/>
+          <p:nvPr/>
+        </p:nvSpPr>
+        <p:spPr>
+          <a:xfrm>
+            <a:off x="5212080" y="1901952"/>
+            <a:ext cx="3429000" cy="591312"/>
+          </a:xfrm>
+          <a:prstGeom prst="rect">
+            <a:avLst/>
+          </a:prstGeom>
+          <a:noFill/>
+        </p:spPr>
+        <p:txBody>
+          <a:bodyPr wrap="square" lIns="0" rIns="0" tIns="0" bIns="0">
+            <a:spAutoFit/>
+          </a:bodyPr>
+          <a:lstStyle/>
+          <a:p>
+            <a:pPr algn="l"/>
+            <a:r>
+              <a:rPr sz="1000" b="0">
+                <a:solidFill>
+                  <a:srgbClr val="2D3748"/>
+                </a:solidFill>
+                <a:latin typeface="Calibri"/>
+              </a:rPr>
+              <a:t>Self-report and deny-listed Quality questions are not answerable from the open web. The residual bottleneck.</a:t>
+            </a:r>
+          </a:p>
+        </p:txBody>
+      </p:sp>
+      <p:sp>
+        <p:nvSpPr>
+          <p:cNvPr id="22" name="Rectangle 21"/>
+          <p:cNvSpPr/>
+          <p:nvPr/>
+        </p:nvSpPr>
+        <p:spPr>
+          <a:xfrm>
+            <a:off x="4800600" y="1719072"/>
+            <a:ext cx="164592" cy="164592"/>
+          </a:xfrm>
+          <a:prstGeom prst="rect">
+            <a:avLst/>
+          </a:prstGeom>
+          <a:solidFill>
+            <a:srgbClr val="D69E2E"/>
+          </a:solidFill>
+          <a:ln>
+            <a:noFill/>
+          </a:ln>
+        </p:spPr>
+        <p:style>
+          <a:lnRef idx="1">
+            <a:schemeClr val="accent1"/>
+          </a:lnRef>
+          <a:fillRef idx="3">
+            <a:schemeClr val="accent1"/>
+          </a:fillRef>
+          <a:effectRef idx="2">
+            <a:schemeClr val="accent1"/>
+          </a:effectRef>
+          <a:fontRef idx="minor">
+            <a:schemeClr val="lt1"/>
+          </a:fontRef>
+        </p:style>
+        <p:txBody>
+          <a:bodyPr rtlCol="0" anchor="ctr"/>
+          <a:lstStyle/>
+          <a:p>
+            <a:pPr algn="ctr"/>
+          </a:p>
+        </p:txBody>
+      </p:sp>
+      <p:sp>
+        <p:nvSpPr>
+          <p:cNvPr id="23" name="TextBox 22"/>
+          <p:cNvSpPr txBox="1"/>
+          <p:nvPr/>
+        </p:nvSpPr>
+        <p:spPr>
+          <a:xfrm>
+            <a:off x="5212080" y="2529840"/>
+            <a:ext cx="3429000" cy="256032"/>
+          </a:xfrm>
+          <a:prstGeom prst="rect">
+            <a:avLst/>
+          </a:prstGeom>
+          <a:noFill/>
+        </p:spPr>
+        <p:txBody>
+          <a:bodyPr wrap="square" lIns="0" rIns="0" tIns="0" bIns="0">
+            <a:spAutoFit/>
+          </a:bodyPr>
+          <a:lstStyle/>
+          <a:p>
+            <a:pPr algn="l"/>
+            <a:r>
+              <a:rPr sz="1100" b="1">
+                <a:solidFill>
+                  <a:srgbClr val="1A202C"/>
+                </a:solidFill>
+                <a:latin typeface="Calibri"/>
+              </a:rPr>
+              <a:t>Recall asymmetry</a:t>
+            </a:r>
+          </a:p>
+        </p:txBody>
+      </p:sp>
+      <p:sp>
+        <p:nvSpPr>
+          <p:cNvPr id="24" name="TextBox 23"/>
+          <p:cNvSpPr txBox="1"/>
+          <p:nvPr/>
+        </p:nvSpPr>
+        <p:spPr>
+          <a:xfrm>
+            <a:off x="5212080" y="2785872"/>
+            <a:ext cx="3429000" cy="591312"/>
+          </a:xfrm>
+          <a:prstGeom prst="rect">
+            <a:avLst/>
+          </a:prstGeom>
+          <a:noFill/>
+        </p:spPr>
+        <p:txBody>
+          <a:bodyPr wrap="square" lIns="0" rIns="0" tIns="0" bIns="0">
+            <a:spAutoFit/>
+          </a:bodyPr>
+          <a:lstStyle/>
+          <a:p>
+            <a:pPr algn="l"/>
+            <a:r>
+              <a:rPr sz="1000" b="0">
+                <a:solidFill>
+                  <a:srgbClr val="2D3748"/>
+                </a:solidFill>
+                <a:latin typeface="Calibri"/>
+              </a:rPr>
+              <a:t>Yes-gold recall 0.60 against no-gold 0.87: the swarm confirms a 'no' more readily than a 'yes' on sparse evidence.</a:t>
+            </a:r>
+          </a:p>
+        </p:txBody>
+      </p:sp>
+      <p:sp>
+        <p:nvSpPr>
+          <p:cNvPr id="25" name="Rectangle 24"/>
+          <p:cNvSpPr/>
+          <p:nvPr/>
+        </p:nvSpPr>
+        <p:spPr>
+          <a:xfrm>
+            <a:off x="4800600" y="2602992"/>
+            <a:ext cx="164592" cy="164592"/>
+          </a:xfrm>
+          <a:prstGeom prst="rect">
+            <a:avLst/>
+          </a:prstGeom>
+          <a:solidFill>
+            <a:srgbClr val="D69E2E"/>
+          </a:solidFill>
+          <a:ln>
+            <a:noFill/>
+          </a:ln>
+        </p:spPr>
+        <p:style>
+          <a:lnRef idx="1">
+            <a:schemeClr val="accent1"/>
+          </a:lnRef>
+          <a:fillRef idx="3">
+            <a:schemeClr val="accent1"/>
+          </a:fillRef>
+          <a:effectRef idx="2">
+            <a:schemeClr val="accent1"/>
+          </a:effectRef>
+          <a:fontRef idx="minor">
+            <a:schemeClr val="lt1"/>
+          </a:fontRef>
+        </p:style>
+        <p:txBody>
+          <a:bodyPr rtlCol="0" anchor="ctr"/>
+          <a:lstStyle/>
+          <a:p>
+            <a:pPr algn="ctr"/>
+          </a:p>
+        </p:txBody>
+      </p:sp>
+      <p:sp>
+        <p:nvSpPr>
+          <p:cNvPr id="26" name="TextBox 25"/>
+          <p:cNvSpPr txBox="1"/>
+          <p:nvPr/>
+        </p:nvSpPr>
+        <p:spPr>
+          <a:xfrm>
+            <a:off x="5212080" y="3413760"/>
+            <a:ext cx="3429000" cy="256032"/>
+          </a:xfrm>
+          <a:prstGeom prst="rect">
+            <a:avLst/>
+          </a:prstGeom>
+          <a:noFill/>
+        </p:spPr>
+        <p:txBody>
+          <a:bodyPr wrap="square" lIns="0" rIns="0" tIns="0" bIns="0">
+            <a:spAutoFit/>
+          </a:bodyPr>
+          <a:lstStyle/>
+          <a:p>
+            <a:pPr algn="l"/>
+            <a:r>
+              <a:rPr sz="1100" b="1">
+                <a:solidFill>
+                  <a:srgbClr val="1A202C"/>
+                </a:solidFill>
+                <a:latin typeface="Calibri"/>
+              </a:rPr>
+              <a:t>Thin-web countries</a:t>
+            </a:r>
+          </a:p>
+        </p:txBody>
+      </p:sp>
+      <p:sp>
+        <p:nvSpPr>
+          <p:cNvPr id="27" name="TextBox 26"/>
+          <p:cNvSpPr txBox="1"/>
+          <p:nvPr/>
+        </p:nvSpPr>
+        <p:spPr>
+          <a:xfrm>
+            <a:off x="5212080" y="3669792"/>
+            <a:ext cx="3429000" cy="591312"/>
+          </a:xfrm>
+          <a:prstGeom prst="rect">
+            <a:avLst/>
+          </a:prstGeom>
+          <a:noFill/>
+        </p:spPr>
+        <p:txBody>
+          <a:bodyPr wrap="square" lIns="0" rIns="0" tIns="0" bIns="0">
+            <a:spAutoFit/>
+          </a:bodyPr>
+          <a:lstStyle/>
+          <a:p>
+            <a:pPr algn="l"/>
+            <a:r>
+              <a:rPr sz="1000" b="0">
+                <a:solidFill>
+                  <a:srgbClr val="2D3748"/>
+                </a:solidFill>
+                <a:latin typeface="Calibri"/>
+              </a:rPr>
+              <a:t>Low-resource languages and sparse results untested at scale; language and difficulty are still confounded.</a:t>
+            </a:r>
+          </a:p>
+        </p:txBody>
+      </p:sp>
+      <p:sp>
+        <p:nvSpPr>
+          <p:cNvPr id="28" name="Rectangle 27"/>
+          <p:cNvSpPr/>
+          <p:nvPr/>
+        </p:nvSpPr>
+        <p:spPr>
+          <a:xfrm>
+            <a:off x="4800600" y="3486912"/>
+            <a:ext cx="164592" cy="164592"/>
+          </a:xfrm>
+          <a:prstGeom prst="rect">
+            <a:avLst/>
+          </a:prstGeom>
+          <a:solidFill>
+            <a:srgbClr val="D69E2E"/>
+          </a:solidFill>
+          <a:ln>
+            <a:noFill/>
+          </a:ln>
+        </p:spPr>
+        <p:style>
+          <a:lnRef idx="1">
+            <a:schemeClr val="accent1"/>
+          </a:lnRef>
+          <a:fillRef idx="3">
+            <a:schemeClr val="accent1"/>
+          </a:fillRef>
+          <a:effectRef idx="2">
+            <a:schemeClr val="accent1"/>
+          </a:effectRef>
+          <a:fontRef idx="minor">
+            <a:schemeClr val="lt1"/>
+          </a:fontRef>
+        </p:style>
+        <p:txBody>
+          <a:bodyPr rtlCol="0" anchor="ctr"/>
+          <a:lstStyle/>
+          <a:p>
+            <a:pPr algn="ctr"/>
+          </a:p>
+        </p:txBody>
+      </p:sp>
+      <p:sp>
+        <p:nvSpPr>
+          <p:cNvPr id="29" name="TextBox 28"/>
+          <p:cNvSpPr txBox="1"/>
+          <p:nvPr/>
+        </p:nvSpPr>
+        <p:spPr>
+          <a:xfrm>
+            <a:off x="457200" y="4850892"/>
+            <a:ext cx="8229600" cy="182880"/>
+          </a:xfrm>
+          <a:prstGeom prst="rect">
+            <a:avLst/>
+          </a:prstGeom>
+          <a:noFill/>
+        </p:spPr>
+        <p:txBody>
+          <a:bodyPr wrap="square" lIns="0" rIns="0" tIns="0" bIns="0">
+            <a:spAutoFit/>
+          </a:bodyPr>
+          <a:lstStyle/>
+          <a:p>
+            <a:pPr algn="l"/>
+            <a:r>
+              <a:rPr sz="800" b="0">
+                <a:solidFill>
+                  <a:srgbClr val="718096"/>
+                </a:solidFill>
+                <a:latin typeface="Calibri"/>
+              </a:rPr>
+              <a:t>ODMI Agent Swarm  ·  Benjy Bream  ·  King's College London  ·  5 / 6</a:t>
+            </a:r>
+          </a:p>
+        </p:txBody>
+      </p:sp>
+    </p:spTree>
+  </p:cSld>
+  <p:clrMapOvr>
+    <a:masterClrMapping/>
+  </p:clrMapOvr>
+</p:sld>
+</file>
+
+<file path=ppt/slides/slide6.xml><?xml version="1.0" encoding="utf-8"?>
+<p:sld xmlns:a="http://schemas.openxmlformats.org/drawingml/2006/main" xmlns:p="http://schemas.openxmlformats.org/presentationml/2006/main" xmlns:r="http://schemas.openxmlformats.org/officeDocument/2006/relationships">
+  <p:cSld>
+    <p:spTree>
+      <p:nvGrpSpPr>
+        <p:cNvPr id="1" name=""/>
+        <p:cNvGrpSpPr/>
+        <p:nvPr/>
+      </p:nvGrpSpPr>
+      <p:grpSpPr/>
+      <p:sp>
+        <p:nvSpPr>
+          <p:cNvPr id="2" name="Rectangle 1"/>
+          <p:cNvSpPr/>
+          <p:nvPr/>
+        </p:nvSpPr>
+        <p:spPr>
+          <a:xfrm>
+            <a:off x="0" y="0"/>
+            <a:ext cx="9144000" cy="960120"/>
+          </a:xfrm>
+          <a:prstGeom prst="rect">
+            <a:avLst/>
+          </a:prstGeom>
+          <a:solidFill>
+            <a:srgbClr val="1A202C"/>
+          </a:solidFill>
+          <a:ln>
+            <a:noFill/>
+          </a:ln>
+        </p:spPr>
+        <p:style>
+          <a:lnRef idx="1">
+            <a:schemeClr val="accent1"/>
+          </a:lnRef>
+          <a:fillRef idx="3">
+            <a:schemeClr val="accent1"/>
+          </a:fillRef>
+          <a:effectRef idx="2">
+            <a:schemeClr val="accent1"/>
+          </a:effectRef>
+          <a:fontRef idx="minor">
+            <a:schemeClr val="lt1"/>
+          </a:fontRef>
+        </p:style>
+        <p:txBody>
+          <a:bodyPr rtlCol="0" anchor="ctr"/>
+          <a:lstStyle/>
+          <a:p>
+            <a:pPr algn="ctr"/>
+          </a:p>
+        </p:txBody>
+      </p:sp>
+      <p:sp>
+        <p:nvSpPr>
+          <p:cNvPr id="3" name="TextBox 2"/>
+          <p:cNvSpPr txBox="1"/>
+          <p:nvPr/>
+        </p:nvSpPr>
+        <p:spPr>
+          <a:xfrm>
+            <a:off x="457200" y="164592"/>
+            <a:ext cx="7772400" cy="228600"/>
+          </a:xfrm>
+          <a:prstGeom prst="rect">
+            <a:avLst/>
+          </a:prstGeom>
+          <a:noFill/>
+        </p:spPr>
+        <p:txBody>
+          <a:bodyPr wrap="square" lIns="0" rIns="0" tIns="0" bIns="0">
+            <a:spAutoFit/>
+          </a:bodyPr>
+          <a:lstStyle/>
+          <a:p>
+            <a:pPr algn="l"/>
+            <a:r>
+              <a:rPr sz="900" b="1">
+                <a:solidFill>
+                  <a:srgbClr val="14B8A6"/>
+                </a:solidFill>
+                <a:latin typeface="Calibri"/>
+              </a:rPr>
+              <a:t>NEXT STEPS AND OPEN QUESTIONS</a:t>
+            </a:r>
+          </a:p>
+        </p:txBody>
+      </p:sp>
+      <p:sp>
+        <p:nvSpPr>
+          <p:cNvPr id="4" name="TextBox 3"/>
+          <p:cNvSpPr txBox="1"/>
+          <p:nvPr/>
+        </p:nvSpPr>
+        <p:spPr>
+          <a:xfrm>
+            <a:off x="457200" y="384048"/>
+            <a:ext cx="7772400" cy="502920"/>
+          </a:xfrm>
+          <a:prstGeom prst="rect">
+            <a:avLst/>
+          </a:prstGeom>
+          <a:noFill/>
+        </p:spPr>
+        <p:txBody>
+          <a:bodyPr wrap="square" lIns="0" rIns="0" tIns="0" bIns="0">
+            <a:spAutoFit/>
+          </a:bodyPr>
+          <a:lstStyle/>
+          <a:p>
+            <a:pPr algn="l"/>
+            <a:r>
+              <a:rPr sz="2400" b="1">
+                <a:solidFill>
+                  <a:srgbClr val="FFFFFF"/>
+                </a:solidFill>
+                <a:latin typeface="Calibri"/>
+              </a:rPr>
+              <a:t>Where I want your opinion</a:t>
+            </a:r>
+          </a:p>
+        </p:txBody>
+      </p:sp>
+      <p:sp>
+        <p:nvSpPr>
+          <p:cNvPr id="5" name="Rectangle 4"/>
+          <p:cNvSpPr/>
+          <p:nvPr/>
+        </p:nvSpPr>
+        <p:spPr>
+          <a:xfrm>
+            <a:off x="457200" y="1143000"/>
+            <a:ext cx="4069080" cy="3246120"/>
+          </a:xfrm>
+          <a:prstGeom prst="rect">
+            <a:avLst/>
+          </a:prstGeom>
+          <a:solidFill>
+            <a:srgbClr val="F7FAFC"/>
+          </a:solidFill>
+          <a:ln w="6350">
+            <a:solidFill>
+              <a:srgbClr val="E2E8F0"/>
+            </a:solidFill>
+          </a:ln>
+        </p:spPr>
+        <p:style>
+          <a:lnRef idx="1">
+            <a:schemeClr val="accent1"/>
+          </a:lnRef>
+          <a:fillRef idx="3">
+            <a:schemeClr val="accent1"/>
+          </a:fillRef>
+          <a:effectRef idx="2">
+            <a:schemeClr val="accent1"/>
+          </a:effectRef>
+          <a:fontRef idx="minor">
+            <a:schemeClr val="lt1"/>
+          </a:fontRef>
+        </p:style>
+        <p:txBody>
+          <a:bodyPr rtlCol="0" anchor="ctr"/>
+          <a:lstStyle/>
+          <a:p>
+            <a:pPr algn="ctr"/>
+          </a:p>
+        </p:txBody>
+      </p:sp>
+      <p:sp>
+        <p:nvSpPr>
+          <p:cNvPr id="6" name="Rectangle 5"/>
+          <p:cNvSpPr/>
+          <p:nvPr/>
+        </p:nvSpPr>
+        <p:spPr>
+          <a:xfrm>
+            <a:off x="457200" y="1143000"/>
+            <a:ext cx="4069080" cy="411480"/>
+          </a:xfrm>
+          <a:prstGeom prst="rect">
+            <a:avLst/>
+          </a:prstGeom>
+          <a:solidFill>
+            <a:srgbClr val="1A202C"/>
+          </a:solidFill>
+          <a:ln>
+            <a:noFill/>
+          </a:ln>
+        </p:spPr>
+        <p:style>
+          <a:lnRef idx="1">
+            <a:schemeClr val="accent1"/>
+          </a:lnRef>
+          <a:fillRef idx="3">
+            <a:schemeClr val="accent1"/>
+          </a:fillRef>
+          <a:effectRef idx="2">
+            <a:schemeClr val="accent1"/>
+          </a:effectRef>
+          <a:fontRef idx="minor">
+            <a:schemeClr val="lt1"/>
+          </a:fontRef>
+        </p:style>
+        <p:txBody>
+          <a:bodyPr rtlCol="0" anchor="ctr"/>
+          <a:lstStyle/>
+          <a:p>
+            <a:pPr algn="ctr"/>
+          </a:p>
+        </p:txBody>
+      </p:sp>
+      <p:sp>
+        <p:nvSpPr>
+          <p:cNvPr id="7" name="TextBox 6"/>
+          <p:cNvSpPr txBox="1"/>
+          <p:nvPr/>
+        </p:nvSpPr>
+        <p:spPr>
+          <a:xfrm>
+            <a:off x="685800" y="1234440"/>
+            <a:ext cx="3611880" cy="274320"/>
+          </a:xfrm>
+          <a:prstGeom prst="rect">
+            <a:avLst/>
+          </a:prstGeom>
+          <a:noFill/>
+        </p:spPr>
+        <p:txBody>
+          <a:bodyPr wrap="square" lIns="0" rIns="0" tIns="0" bIns="0">
+            <a:spAutoFit/>
+          </a:bodyPr>
+          <a:lstStyle/>
+          <a:p>
+            <a:pPr algn="l"/>
+            <a:r>
+              <a:rPr sz="1100" b="1">
+                <a:solidFill>
+                  <a:srgbClr val="FFFFFF"/>
+                </a:solidFill>
+                <a:latin typeface="Calibri"/>
+              </a:rPr>
+              <a:t>NEXT STEPS</a:t>
+            </a:r>
+          </a:p>
+        </p:txBody>
+      </p:sp>
+      <p:sp>
+        <p:nvSpPr>
+          <p:cNvPr id="8" name="TextBox 7"/>
+          <p:cNvSpPr txBox="1"/>
+          <p:nvPr/>
+        </p:nvSpPr>
+        <p:spPr>
+          <a:xfrm>
+            <a:off x="1051560" y="1645920"/>
+            <a:ext cx="3429000" cy="256032"/>
+          </a:xfrm>
+          <a:prstGeom prst="rect">
+            <a:avLst/>
+          </a:prstGeom>
+          <a:noFill/>
+        </p:spPr>
+        <p:txBody>
+          <a:bodyPr wrap="square" lIns="0" rIns="0" tIns="0" bIns="0">
+            <a:spAutoFit/>
+          </a:bodyPr>
+          <a:lstStyle/>
+          <a:p>
+            <a:pPr algn="l"/>
+            <a:r>
+              <a:rPr sz="1100" b="1">
+                <a:solidFill>
+                  <a:srgbClr val="1A202C"/>
+                </a:solidFill>
+                <a:latin typeface="Calibri"/>
+              </a:rPr>
+              <a:t>Freeze a held-out test stratum</a:t>
+            </a:r>
+          </a:p>
+        </p:txBody>
+      </p:sp>
+      <p:sp>
+        <p:nvSpPr>
+          <p:cNvPr id="9" name="TextBox 8"/>
+          <p:cNvSpPr txBox="1"/>
+          <p:nvPr/>
+        </p:nvSpPr>
+        <p:spPr>
+          <a:xfrm>
+            <a:off x="1051560" y="1901952"/>
+            <a:ext cx="3429000" cy="591312"/>
+          </a:xfrm>
+          <a:prstGeom prst="rect">
+            <a:avLst/>
+          </a:prstGeom>
+          <a:noFill/>
+        </p:spPr>
+        <p:txBody>
+          <a:bodyPr wrap="square" lIns="0" rIns="0" tIns="0" bIns="0">
+            <a:spAutoFit/>
+          </a:bodyPr>
+          <a:lstStyle/>
+          <a:p>
+            <a:pPr algn="l"/>
+            <a:r>
+              <a:rPr sz="1000" b="0">
+                <a:solidFill>
+                  <a:srgbClr val="2D3748"/>
+                </a:solidFill>
+                <a:latin typeface="Calibri"/>
+              </a:rPr>
+              <a:t>Tune on a subset, report final accuracy on unseen countries against the contemporaneous web.</a:t>
+            </a:r>
+          </a:p>
+        </p:txBody>
+      </p:sp>
+      <p:sp>
+        <p:nvSpPr>
+          <p:cNvPr id="10" name="Rectangle 9"/>
+          <p:cNvSpPr/>
+          <p:nvPr/>
+        </p:nvSpPr>
+        <p:spPr>
+          <a:xfrm>
+            <a:off x="640080" y="1719072"/>
+            <a:ext cx="164592" cy="164592"/>
+          </a:xfrm>
+          <a:prstGeom prst="rect">
+            <a:avLst/>
+          </a:prstGeom>
+          <a:solidFill>
+            <a:srgbClr val="0D9488"/>
+          </a:solidFill>
+          <a:ln>
+            <a:noFill/>
+          </a:ln>
+        </p:spPr>
+        <p:style>
+          <a:lnRef idx="1">
+            <a:schemeClr val="accent1"/>
+          </a:lnRef>
+          <a:fillRef idx="3">
+            <a:schemeClr val="accent1"/>
+          </a:fillRef>
+          <a:effectRef idx="2">
+            <a:schemeClr val="accent1"/>
+          </a:effectRef>
+          <a:fontRef idx="minor">
+            <a:schemeClr val="lt1"/>
+          </a:fontRef>
+        </p:style>
+        <p:txBody>
+          <a:bodyPr rtlCol="0" anchor="ctr"/>
+          <a:lstStyle/>
+          <a:p>
+            <a:pPr algn="ctr"/>
+          </a:p>
+        </p:txBody>
+      </p:sp>
+      <p:sp>
+        <p:nvSpPr>
+          <p:cNvPr id="11" name="TextBox 10"/>
+          <p:cNvSpPr txBox="1"/>
+          <p:nvPr/>
+        </p:nvSpPr>
+        <p:spPr>
+          <a:xfrm>
+            <a:off x="1051560" y="2529840"/>
+            <a:ext cx="3429000" cy="256032"/>
+          </a:xfrm>
+          <a:prstGeom prst="rect">
+            <a:avLst/>
+          </a:prstGeom>
+          <a:noFill/>
+        </p:spPr>
+        <p:txBody>
+          <a:bodyPr wrap="square" lIns="0" rIns="0" tIns="0" bIns="0">
+            <a:spAutoFit/>
+          </a:bodyPr>
+          <a:lstStyle/>
+          <a:p>
+            <a:pPr algn="l"/>
+            <a:r>
+              <a:rPr sz="1100" b="1">
+                <a:solidFill>
+                  <a:srgbClr val="1A202C"/>
+                </a:solidFill>
+                <a:latin typeface="Calibri"/>
+              </a:rPr>
+              <a:t>Run the pre-registered set</a:t>
+            </a:r>
+          </a:p>
+        </p:txBody>
+      </p:sp>
+      <p:sp>
+        <p:nvSpPr>
+          <p:cNvPr id="12" name="TextBox 11"/>
+          <p:cNvSpPr txBox="1"/>
+          <p:nvPr/>
+        </p:nvSpPr>
+        <p:spPr>
+          <a:xfrm>
+            <a:off x="1051560" y="2785872"/>
+            <a:ext cx="3429000" cy="591312"/>
+          </a:xfrm>
+          <a:prstGeom prst="rect">
+            <a:avLst/>
+          </a:prstGeom>
+          <a:noFill/>
+        </p:spPr>
+        <p:txBody>
+          <a:bodyPr wrap="square" lIns="0" rIns="0" tIns="0" bIns="0">
+            <a:spAutoFit/>
+          </a:bodyPr>
+          <a:lstStyle/>
+          <a:p>
+            <a:pPr algn="l"/>
+            <a:r>
+              <a:rPr sz="1000" b="0">
+                <a:solidFill>
+                  <a:srgbClr val="2D3748"/>
+                </a:solidFill>
+                <a:latin typeface="Calibri"/>
+              </a:rPr>
+              <a:t>EXP-6 / 7 / 8 / 9 / 10 once quota resets; build the accuracy-cost surface.</a:t>
+            </a:r>
+          </a:p>
+        </p:txBody>
+      </p:sp>
+      <p:sp>
+        <p:nvSpPr>
+          <p:cNvPr id="13" name="Rectangle 12"/>
+          <p:cNvSpPr/>
+          <p:nvPr/>
+        </p:nvSpPr>
+        <p:spPr>
+          <a:xfrm>
+            <a:off x="640080" y="2602992"/>
+            <a:ext cx="164592" cy="164592"/>
+          </a:xfrm>
+          <a:prstGeom prst="rect">
+            <a:avLst/>
+          </a:prstGeom>
+          <a:solidFill>
+            <a:srgbClr val="0D9488"/>
+          </a:solidFill>
+          <a:ln>
+            <a:noFill/>
+          </a:ln>
+        </p:spPr>
+        <p:style>
+          <a:lnRef idx="1">
+            <a:schemeClr val="accent1"/>
+          </a:lnRef>
+          <a:fillRef idx="3">
+            <a:schemeClr val="accent1"/>
+          </a:fillRef>
+          <a:effectRef idx="2">
+            <a:schemeClr val="accent1"/>
+          </a:effectRef>
+          <a:fontRef idx="minor">
+            <a:schemeClr val="lt1"/>
+          </a:fontRef>
+        </p:style>
+        <p:txBody>
+          <a:bodyPr rtlCol="0" anchor="ctr"/>
+          <a:lstStyle/>
+          <a:p>
+            <a:pPr algn="ctr"/>
+          </a:p>
+        </p:txBody>
+      </p:sp>
+      <p:sp>
+        <p:nvSpPr>
+          <p:cNvPr id="14" name="TextBox 13"/>
+          <p:cNvSpPr txBox="1"/>
+          <p:nvPr/>
+        </p:nvSpPr>
+        <p:spPr>
+          <a:xfrm>
+            <a:off x="1051560" y="3413760"/>
+            <a:ext cx="3429000" cy="256032"/>
+          </a:xfrm>
+          <a:prstGeom prst="rect">
+            <a:avLst/>
+          </a:prstGeom>
+          <a:noFill/>
+        </p:spPr>
+        <p:txBody>
+          <a:bodyPr wrap="square" lIns="0" rIns="0" tIns="0" bIns="0">
+            <a:spAutoFit/>
+          </a:bodyPr>
+          <a:lstStyle/>
+          <a:p>
+            <a:pPr algn="l"/>
+            <a:r>
+              <a:rPr sz="1100" b="1">
+                <a:solidFill>
+                  <a:srgbClr val="1A202C"/>
+                </a:solidFill>
+                <a:latin typeface="Calibri"/>
+              </a:rPr>
+              <a:t>Six-country sweep</a:t>
+            </a:r>
+          </a:p>
+        </p:txBody>
+      </p:sp>
+      <p:sp>
+        <p:nvSpPr>
+          <p:cNvPr id="15" name="TextBox 14"/>
+          <p:cNvSpPr txBox="1"/>
+          <p:nvPr/>
+        </p:nvSpPr>
+        <p:spPr>
+          <a:xfrm>
+            <a:off x="1051560" y="3669792"/>
+            <a:ext cx="3429000" cy="591312"/>
+          </a:xfrm>
+          <a:prstGeom prst="rect">
+            <a:avLst/>
+          </a:prstGeom>
+          <a:noFill/>
+        </p:spPr>
+        <p:txBody>
+          <a:bodyPr wrap="square" lIns="0" rIns="0" tIns="0" bIns="0">
+            <a:spAutoFit/>
+          </a:bodyPr>
+          <a:lstStyle/>
+          <a:p>
+            <a:pPr algn="l"/>
+            <a:r>
+              <a:rPr sz="1000" b="0">
+                <a:solidFill>
+                  <a:srgbClr val="2D3748"/>
+                </a:solidFill>
+                <a:latin typeface="Calibri"/>
+              </a:rPr>
+              <a:t>Wealth x maturity matrix across all 143 questions, base-rate checked per cell.</a:t>
+            </a:r>
+          </a:p>
+        </p:txBody>
+      </p:sp>
+      <p:sp>
+        <p:nvSpPr>
+          <p:cNvPr id="16" name="Rectangle 15"/>
+          <p:cNvSpPr/>
+          <p:nvPr/>
+        </p:nvSpPr>
+        <p:spPr>
+          <a:xfrm>
+            <a:off x="640080" y="3486912"/>
+            <a:ext cx="164592" cy="164592"/>
+          </a:xfrm>
+          <a:prstGeom prst="rect">
+            <a:avLst/>
+          </a:prstGeom>
+          <a:solidFill>
+            <a:srgbClr val="0D9488"/>
+          </a:solidFill>
+          <a:ln>
+            <a:noFill/>
+          </a:ln>
+        </p:spPr>
+        <p:style>
+          <a:lnRef idx="1">
+            <a:schemeClr val="accent1"/>
+          </a:lnRef>
+          <a:fillRef idx="3">
+            <a:schemeClr val="accent1"/>
+          </a:fillRef>
+          <a:effectRef idx="2">
+            <a:schemeClr val="accent1"/>
+          </a:effectRef>
+          <a:fontRef idx="minor">
+            <a:schemeClr val="lt1"/>
+          </a:fontRef>
+        </p:style>
+        <p:txBody>
+          <a:bodyPr rtlCol="0" anchor="ctr"/>
+          <a:lstStyle/>
+          <a:p>
+            <a:pPr algn="ctr"/>
+          </a:p>
+        </p:txBody>
+      </p:sp>
+      <p:sp>
+        <p:nvSpPr>
+          <p:cNvPr id="17" name="Rectangle 16"/>
+          <p:cNvSpPr/>
+          <p:nvPr/>
+        </p:nvSpPr>
+        <p:spPr>
+          <a:xfrm>
+            <a:off x="4617720" y="1143000"/>
+            <a:ext cx="4069080" cy="3246120"/>
+          </a:xfrm>
+          <a:prstGeom prst="rect">
+            <a:avLst/>
+          </a:prstGeom>
+          <a:solidFill>
+            <a:srgbClr val="F7FAFC"/>
+          </a:solidFill>
+          <a:ln w="6350">
+            <a:solidFill>
+              <a:srgbClr val="E2E8F0"/>
+            </a:solidFill>
+          </a:ln>
+        </p:spPr>
+        <p:style>
+          <a:lnRef idx="1">
+            <a:schemeClr val="accent1"/>
+          </a:lnRef>
+          <a:fillRef idx="3">
+            <a:schemeClr val="accent1"/>
+          </a:fillRef>
+          <a:effectRef idx="2">
+            <a:schemeClr val="accent1"/>
+          </a:effectRef>
+          <a:fontRef idx="minor">
+            <a:schemeClr val="lt1"/>
+          </a:fontRef>
+        </p:style>
+        <p:txBody>
+          <a:bodyPr rtlCol="0" anchor="ctr"/>
+          <a:lstStyle/>
+          <a:p>
+            <a:pPr algn="ctr"/>
+          </a:p>
+        </p:txBody>
+      </p:sp>
+      <p:sp>
+        <p:nvSpPr>
+          <p:cNvPr id="18" name="Rectangle 17"/>
+          <p:cNvSpPr/>
+          <p:nvPr/>
+        </p:nvSpPr>
+        <p:spPr>
+          <a:xfrm>
+            <a:off x="4617720" y="1143000"/>
+            <a:ext cx="4069080" cy="411480"/>
+          </a:xfrm>
+          <a:prstGeom prst="rect">
+            <a:avLst/>
+          </a:prstGeom>
+          <a:solidFill>
             <a:srgbClr val="1E3A5F"/>
           </a:solidFill>
           <a:ln>
@@ -7684,7 +7950,7 @@
                 </a:solidFill>
                 <a:latin typeface="Calibri"/>
               </a:rPr>
-              <a:t>ODMI Agent Swarm  ·  Benjy Bream  ·  King's College London  ·  5 / 5</a:t>
+              <a:t>ODMI Agent Swarm  ·  Benjy Bream  ·  King's College London  ·  6 / 6</a:t>
             </a:r>
           </a:p>
         </p:txBody>

</xml_diff>